<commit_message>
actualización de definicion de Agente IA
actualice el material para que contenga una lamina con la explicacion de que es un Agente de IA
</commit_message>
<xml_diff>
--- a/slides/pptx/m3-sesion1-patrones-de-agentes.pptx
+++ b/slides/pptx/m3-sesion1-patrones-de-agentes.pptx
@@ -18,7 +18,7 @@
     <p:sldId id="262" r:id="rId9"/>
     <p:sldId id="263" r:id="rId10"/>
     <p:sldId id="264" r:id="rId11"/>
-    <p:sldId id="265" r:id="rId12"/>
+    <p:sldId id="299" r:id="rId12"/>
     <p:sldId id="292" r:id="rId13"/>
     <p:sldId id="267" r:id="rId14"/>
     <p:sldId id="268" r:id="rId15"/>
@@ -383,18 +383,6 @@
       </p:grpSpPr>
       <p:sp>
         <p:nvSpPr>
-          <p:cNvPr id="2" name="Slide Image Placeholder 1"/>
-          <p:cNvSpPr>
-            <a:spLocks noGrp="1" noRot="1" noChangeAspect="1"/>
-          </p:cNvSpPr>
-          <p:nvPr>
-            <p:ph type="sldImg"/>
-          </p:nvPr>
-        </p:nvSpPr>
-        <p:spPr/>
-      </p:sp>
-      <p:sp>
-        <p:nvSpPr>
           <p:cNvPr id="3" name="Notes Placeholder 2"/>
           <p:cNvSpPr>
             <a:spLocks noGrp="1"/>
@@ -409,41 +397,12 @@
           <a:lstStyle/>
           <a:p>
             <a:r>
-              <a:rPr lang="en-US" dirty="0"/>
-              <a:t>Workflow contra agente y el bucle. Pide a la clase un ejemplo de su trabajo para cada columna.</a:t>
-            </a:r>
-          </a:p>
-        </p:txBody>
-      </p:sp>
-      <p:sp>
-        <p:nvSpPr>
-          <p:cNvPr id="4" name="Slide Number Placeholder 3"/>
-          <p:cNvSpPr>
-            <a:spLocks noGrp="1"/>
-          </p:cNvSpPr>
-          <p:nvPr>
-            <p:ph type="sldNum" sz="quarter" idx="10"/>
-          </p:nvPr>
-        </p:nvSpPr>
-        <p:spPr/>
-        <p:txBody>
-          <a:bodyPr/>
-          <a:lstStyle/>
-          <a:p>
-            <a:fld id="{F7021451-1387-4CA6-816F-3879F97B5CBC}" type="slidenum">
-              <a:rPr lang="en-US"/>
-              <a:t>11</a:t>
-            </a:fld>
-            <a:endParaRPr lang="en-US"/>
+              <a:t>Definición: un componente de software cuyo objetivo es actuar de forma autónoma simulando a un humano en la ejecución de una o varias tareas. Tres capacidades lo distinguen. 1) Se comunica en lenguaje natural, como una persona: entiende lo que le pides y te responde sin formularios ni comandos. 2) Elige qué herramienta usar y la usa, como una persona que decide si abre un archivo, consulta un sistema o corre una prueba. 3) Es autónomo: decide qué usar y cuándo, paso a paso, sin que alguien le dicte cada movimiento; salvo que explícitamente se le supervise, por ejemplo pidiendo aprobación antes de algo irreversible. Pregunta para el grupo: ¿un chatbot que solo responde preguntas es un agente? Le faltan las herramientas y la autonomía: conversa, pero no actúa.</a:t>
+            </a:r>
           </a:p>
         </p:txBody>
       </p:sp>
     </p:spTree>
-    <p:extLst>
-      <p:ext uri="{BB962C8B-B14F-4D97-AF65-F5344CB8AC3E}">
-        <p14:creationId xmlns:p14="http://schemas.microsoft.com/office/powerpoint/2010/main" val="1024086991"/>
-      </p:ext>
-    </p:extLst>
   </p:cSld>
   <p:clrMapOvr>
     <a:masterClrMapping/>
@@ -9965,15 +9924,7 @@
 
 <file path=ppt/slides/slide11.xml><?xml version="1.0" encoding="utf-8"?>
 <p:sld xmlns:a="http://schemas.openxmlformats.org/drawingml/2006/main" xmlns:r="http://schemas.openxmlformats.org/officeDocument/2006/relationships" xmlns:p="http://schemas.openxmlformats.org/presentationml/2006/main">
-  <p:cSld name="Slide 10">
-    <p:bg>
-      <p:bgPr>
-        <a:solidFill>
-          <a:srgbClr val="EDE8DC"/>
-        </a:solidFill>
-        <a:effectLst/>
-      </p:bgPr>
-    </p:bg>
+  <p:cSld>
     <p:spTree>
       <p:nvGrpSpPr>
         <p:cNvPr id="1" name=""/>
@@ -9990,7 +9941,34 @@
       </p:grpSpPr>
       <p:sp>
         <p:nvSpPr>
-          <p:cNvPr id="2" name="s10-forma-1"/>
+          <p:cNvPr id="2" name="s16-forma-1"/>
+          <p:cNvSpPr/>
+          <p:nvPr/>
+        </p:nvSpPr>
+        <p:spPr>
+          <a:xfrm>
+            <a:off x="853390" y="520961"/>
+            <a:ext cx="10484915" cy="5713"/>
+          </a:xfrm>
+          <a:prstGeom prst="rect">
+            <a:avLst/>
+          </a:prstGeom>
+          <a:solidFill>
+            <a:srgbClr val="C6BFAE"/>
+          </a:solidFill>
+          <a:ln/>
+        </p:spPr>
+        <p:txBody>
+          <a:bodyPr/>
+          <a:lstStyle/>
+          <a:p>
+            <a:endParaRPr lang="es-MX"/>
+          </a:p>
+        </p:txBody>
+      </p:sp>
+      <p:sp>
+        <p:nvSpPr>
+          <p:cNvPr id="3" name="s16-forma-2"/>
           <p:cNvSpPr/>
           <p:nvPr/>
         </p:nvSpPr>
@@ -10017,7 +9995,7 @@
       </p:sp>
       <p:sp>
         <p:nvSpPr>
-          <p:cNvPr id="3" name="s10-texto-2"/>
+          <p:cNvPr id="4" name="s16-texto-3"/>
           <p:cNvSpPr txBox="1"/>
           <p:nvPr/>
         </p:nvSpPr>
@@ -10059,7 +10037,7 @@
       </p:sp>
       <p:sp>
         <p:nvSpPr>
-          <p:cNvPr id="4" name="s10-texto-3"/>
+          <p:cNvPr id="5" name="s16-texto-4"/>
           <p:cNvSpPr txBox="1"/>
           <p:nvPr/>
         </p:nvSpPr>
@@ -10093,7 +10071,7 @@
                 <a:ea typeface="Courier New" pitchFamily="34" charset="-122"/>
                 <a:cs typeface="Courier New" pitchFamily="34" charset="-120"/>
               </a:rPr>
-              <a:t>0:10 · 15 min</a:t>
+              <a:t>—:— · 5 min</a:t>
             </a:r>
             <a:endParaRPr lang="en-US" sz="807" dirty="0"/>
           </a:p>
@@ -10101,14 +10079,14 @@
       </p:sp>
       <p:sp>
         <p:nvSpPr>
-          <p:cNvPr id="5" name="s10-texto-4"/>
-          <p:cNvSpPr txBox="1"/>
-          <p:nvPr/>
-        </p:nvSpPr>
-        <p:spPr>
-          <a:xfrm>
-            <a:off x="853390" y="2679877"/>
-            <a:ext cx="11114010" cy="125688"/>
+          <p:cNvPr id="6" name="s16-texto-5"/>
+          <p:cNvSpPr txBox="1"/>
+          <p:nvPr/>
+        </p:nvSpPr>
+        <p:spPr>
+          <a:xfrm>
+            <a:off x="1342572" y="1245450"/>
+            <a:ext cx="10076945" cy="131401"/>
           </a:xfrm>
           <a:prstGeom prst="rect">
             <a:avLst/>
@@ -10122,12 +10100,12 @@
           <a:p>
             <a:pPr marL="0" indent="0" algn="l">
               <a:lnSpc>
-                <a:spcPts val="1043"/>
-              </a:lnSpc>
-              <a:buNone/>
-            </a:pPr>
-            <a:r>
-              <a:rPr lang="en-US" sz="869" b="1" kern="0" spc="209" dirty="0">
+                <a:spcPts val="1080"/>
+              </a:lnSpc>
+              <a:buNone/>
+            </a:pPr>
+            <a:r>
+              <a:rPr lang="en-US" sz="900" b="1" kern="0" spc="135" dirty="0">
                 <a:solidFill>
                   <a:srgbClr val="0033A0"/>
                 </a:solidFill>
@@ -10135,49 +10113,22 @@
                 <a:ea typeface="Courier New" pitchFamily="34" charset="-122"/>
                 <a:cs typeface="Courier New" pitchFamily="34" charset="-120"/>
               </a:rPr>
-              <a:t>BLOQUE 1.1</a:t>
-            </a:r>
-            <a:endParaRPr lang="en-US" sz="869" dirty="0"/>
-          </a:p>
-        </p:txBody>
-      </p:sp>
-      <p:sp>
-        <p:nvSpPr>
-          <p:cNvPr id="6" name="s10-forma-5"/>
-          <p:cNvSpPr/>
-          <p:nvPr/>
-        </p:nvSpPr>
-        <p:spPr>
-          <a:xfrm>
-            <a:off x="853390" y="3768306"/>
-            <a:ext cx="722704" cy="22852"/>
-          </a:xfrm>
-          <a:prstGeom prst="rect">
-            <a:avLst/>
-          </a:prstGeom>
-          <a:solidFill>
-            <a:srgbClr val="0033A0"/>
-          </a:solidFill>
-          <a:ln/>
-        </p:spPr>
-        <p:txBody>
-          <a:bodyPr/>
-          <a:lstStyle/>
-          <a:p>
-            <a:endParaRPr lang="es-MX"/>
-          </a:p>
-        </p:txBody>
-      </p:sp>
-      <p:sp>
-        <p:nvSpPr>
-          <p:cNvPr id="7" name="s10-texto-6"/>
-          <p:cNvSpPr txBox="1"/>
-          <p:nvPr/>
-        </p:nvSpPr>
-        <p:spPr>
-          <a:xfrm>
-            <a:off x="853390" y="2960889"/>
-            <a:ext cx="7149222" cy="634151"/>
+              <a:t>AGENTES DE IA · DEFINICIÓN</a:t>
+            </a:r>
+            <a:endParaRPr lang="en-US" sz="900" dirty="0"/>
+          </a:p>
+        </p:txBody>
+      </p:sp>
+      <p:sp>
+        <p:nvSpPr>
+          <p:cNvPr id="7" name="s16-texto-6"/>
+          <p:cNvSpPr txBox="1"/>
+          <p:nvPr/>
+        </p:nvSpPr>
+        <p:spPr>
+          <a:xfrm>
+            <a:off x="1342572" y="1451120"/>
+            <a:ext cx="10076945" cy="428480"/>
           </a:xfrm>
           <a:prstGeom prst="rect">
             <a:avLst/>
@@ -10191,12 +10142,12 @@
           <a:p>
             <a:pPr marL="0" indent="0" algn="l">
               <a:lnSpc>
-                <a:spcPts val="4582"/>
-              </a:lnSpc>
-              <a:buNone/>
-            </a:pPr>
-            <a:r>
-              <a:rPr lang="en-US" sz="4242" b="1" kern="0" spc="-64" dirty="0">
+                <a:spcPts val="3167"/>
+              </a:lnSpc>
+              <a:buNone/>
+            </a:pPr>
+            <a:r>
+              <a:rPr lang="en-US" sz="2879" b="1" kern="0" spc="-29" dirty="0">
                 <a:solidFill>
                   <a:srgbClr val="16181D"/>
                 </a:solidFill>
@@ -10204,66 +10155,22 @@
                 <a:ea typeface="Georgia" pitchFamily="34" charset="-122"/>
                 <a:cs typeface="Georgia" pitchFamily="34" charset="-120"/>
               </a:rPr>
-              <a:t>¿</a:t>
-            </a:r>
-            <a:r>
-              <a:rPr lang="en-US" sz="4242" b="1" kern="0" spc="-64" dirty="0" err="1">
-                <a:solidFill>
-                  <a:srgbClr val="16181D"/>
-                </a:solidFill>
-                <a:latin typeface="Georgia" pitchFamily="34" charset="0"/>
-                <a:ea typeface="Georgia" pitchFamily="34" charset="-122"/>
-                <a:cs typeface="Georgia" pitchFamily="34" charset="-120"/>
-              </a:rPr>
-              <a:t>Qué</a:t>
-            </a:r>
-            <a:r>
-              <a:rPr lang="en-US" sz="4242" b="1" kern="0" spc="-64" dirty="0">
-                <a:solidFill>
-                  <a:srgbClr val="16181D"/>
-                </a:solidFill>
-                <a:latin typeface="Georgia" pitchFamily="34" charset="0"/>
-                <a:ea typeface="Georgia" pitchFamily="34" charset="-122"/>
-                <a:cs typeface="Georgia" pitchFamily="34" charset="-120"/>
-              </a:rPr>
-              <a:t> es un </a:t>
-            </a:r>
-            <a:r>
-              <a:rPr lang="en-US" sz="4242" b="1" kern="0" spc="-64" dirty="0" err="1">
-                <a:solidFill>
-                  <a:srgbClr val="16181D"/>
-                </a:solidFill>
-                <a:latin typeface="Georgia" pitchFamily="34" charset="0"/>
-                <a:ea typeface="Georgia" pitchFamily="34" charset="-122"/>
-                <a:cs typeface="Georgia" pitchFamily="34" charset="-120"/>
-              </a:rPr>
-              <a:t>agente</a:t>
-            </a:r>
-            <a:r>
-              <a:rPr lang="en-US" sz="4242" b="1" kern="0" spc="-64" dirty="0">
-                <a:solidFill>
-                  <a:srgbClr val="16181D"/>
-                </a:solidFill>
-                <a:latin typeface="Georgia" pitchFamily="34" charset="0"/>
-                <a:ea typeface="Georgia" pitchFamily="34" charset="-122"/>
-                <a:cs typeface="Georgia" pitchFamily="34" charset="-120"/>
-              </a:rPr>
-              <a:t> de IA?</a:t>
-            </a:r>
-            <a:endParaRPr lang="en-US" sz="4242" dirty="0"/>
-          </a:p>
-        </p:txBody>
-      </p:sp>
-      <p:sp>
-        <p:nvSpPr>
-          <p:cNvPr id="8" name="s10-texto-7"/>
-          <p:cNvSpPr txBox="1"/>
-          <p:nvPr/>
-        </p:nvSpPr>
-        <p:spPr>
-          <a:xfrm>
-            <a:off x="853390" y="3969960"/>
-            <a:ext cx="7778274" cy="239949"/>
+              <a:t>¿Qué es un agente de IA?</a:t>
+            </a:r>
+            <a:endParaRPr lang="en-US" sz="2879" dirty="0"/>
+          </a:p>
+        </p:txBody>
+      </p:sp>
+      <p:sp>
+        <p:nvSpPr>
+          <p:cNvPr id="30" name="s16-texto-29"/>
+          <p:cNvSpPr txBox="1"/>
+          <p:nvPr/>
+        </p:nvSpPr>
+        <p:spPr>
+          <a:xfrm>
+            <a:off x="1342572" y="6158691"/>
+            <a:ext cx="10076945" cy="154253"/>
           </a:xfrm>
           <a:prstGeom prst="rect">
             <a:avLst/>
@@ -10277,12 +10184,12 @@
           <a:p>
             <a:pPr marL="0" indent="0" algn="l">
               <a:lnSpc>
-                <a:spcPts val="2430"/>
-              </a:lnSpc>
-              <a:buNone/>
-            </a:pPr>
-            <a:r>
-              <a:rPr lang="en-US" sz="1676" b="1" dirty="0" err="1">
+                <a:spcPts val="1296"/>
+              </a:lnSpc>
+              <a:buNone/>
+            </a:pPr>
+            <a:r>
+              <a:rPr lang="en-US" sz="1080" dirty="0">
                 <a:solidFill>
                   <a:srgbClr val="585E6F"/>
                 </a:solidFill>
@@ -10290,295 +10197,42 @@
                 <a:ea typeface="Arial" pitchFamily="34" charset="-122"/>
                 <a:cs typeface="Arial" pitchFamily="34" charset="-120"/>
               </a:rPr>
-              <a:t>Definición</a:t>
-            </a:r>
-            <a:r>
-              <a:rPr lang="en-US" sz="1676" b="1" dirty="0">
-                <a:solidFill>
-                  <a:srgbClr val="585E6F"/>
-                </a:solidFill>
-                <a:latin typeface="Arial" pitchFamily="34" charset="0"/>
-                <a:ea typeface="Arial" pitchFamily="34" charset="-122"/>
-                <a:cs typeface="Arial" pitchFamily="34" charset="-120"/>
-              </a:rPr>
-              <a:t>: Un </a:t>
-            </a:r>
-            <a:r>
-              <a:rPr lang="en-US" sz="1676" b="1" dirty="0" err="1">
-                <a:solidFill>
-                  <a:srgbClr val="585E6F"/>
-                </a:solidFill>
-                <a:latin typeface="Arial" pitchFamily="34" charset="0"/>
-                <a:ea typeface="Arial" pitchFamily="34" charset="-122"/>
-                <a:cs typeface="Arial" pitchFamily="34" charset="-120"/>
-              </a:rPr>
-              <a:t>componente</a:t>
-            </a:r>
-            <a:r>
-              <a:rPr lang="en-US" sz="1676" b="1" dirty="0">
-                <a:solidFill>
-                  <a:srgbClr val="585E6F"/>
-                </a:solidFill>
-                <a:latin typeface="Arial" pitchFamily="34" charset="0"/>
-                <a:ea typeface="Arial" pitchFamily="34" charset="-122"/>
-                <a:cs typeface="Arial" pitchFamily="34" charset="-120"/>
-              </a:rPr>
-              <a:t> de Software </a:t>
-            </a:r>
-            <a:r>
-              <a:rPr lang="en-US" sz="1676" b="1" dirty="0" err="1">
-                <a:solidFill>
-                  <a:srgbClr val="585E6F"/>
-                </a:solidFill>
-                <a:latin typeface="Arial" pitchFamily="34" charset="0"/>
-                <a:ea typeface="Arial" pitchFamily="34" charset="-122"/>
-                <a:cs typeface="Arial" pitchFamily="34" charset="-120"/>
-              </a:rPr>
-              <a:t>cuyo</a:t>
-            </a:r>
-            <a:r>
-              <a:rPr lang="en-US" sz="1676" b="1" dirty="0">
-                <a:solidFill>
-                  <a:srgbClr val="585E6F"/>
-                </a:solidFill>
-                <a:latin typeface="Arial" pitchFamily="34" charset="0"/>
-                <a:ea typeface="Arial" pitchFamily="34" charset="-122"/>
-                <a:cs typeface="Arial" pitchFamily="34" charset="-120"/>
-              </a:rPr>
-              <a:t> </a:t>
-            </a:r>
-            <a:r>
-              <a:rPr lang="en-US" sz="1676" b="1" dirty="0" err="1">
-                <a:solidFill>
-                  <a:srgbClr val="585E6F"/>
-                </a:solidFill>
-                <a:latin typeface="Arial" pitchFamily="34" charset="0"/>
-                <a:ea typeface="Arial" pitchFamily="34" charset="-122"/>
-                <a:cs typeface="Arial" pitchFamily="34" charset="-120"/>
-              </a:rPr>
-              <a:t>objetivo</a:t>
-            </a:r>
-            <a:r>
-              <a:rPr lang="en-US" sz="1676" b="1" dirty="0">
-                <a:solidFill>
-                  <a:srgbClr val="585E6F"/>
-                </a:solidFill>
-                <a:latin typeface="Arial" pitchFamily="34" charset="0"/>
-                <a:ea typeface="Arial" pitchFamily="34" charset="-122"/>
-                <a:cs typeface="Arial" pitchFamily="34" charset="-120"/>
-              </a:rPr>
-              <a:t> es </a:t>
-            </a:r>
-            <a:r>
-              <a:rPr lang="en-US" sz="1676" b="1" dirty="0" err="1">
-                <a:solidFill>
-                  <a:srgbClr val="585E6F"/>
-                </a:solidFill>
-                <a:latin typeface="Arial" pitchFamily="34" charset="0"/>
-                <a:ea typeface="Arial" pitchFamily="34" charset="-122"/>
-                <a:cs typeface="Arial" pitchFamily="34" charset="-120"/>
-              </a:rPr>
-              <a:t>actuar</a:t>
-            </a:r>
-            <a:r>
-              <a:rPr lang="en-US" sz="1676" b="1" dirty="0">
-                <a:solidFill>
-                  <a:srgbClr val="585E6F"/>
-                </a:solidFill>
-                <a:latin typeface="Arial" pitchFamily="34" charset="0"/>
-                <a:ea typeface="Arial" pitchFamily="34" charset="-122"/>
-                <a:cs typeface="Arial" pitchFamily="34" charset="-120"/>
-              </a:rPr>
-              <a:t> de forma </a:t>
-            </a:r>
-            <a:r>
-              <a:rPr lang="en-US" sz="1676" b="1" dirty="0" err="1">
-                <a:solidFill>
-                  <a:srgbClr val="585E6F"/>
-                </a:solidFill>
-                <a:latin typeface="Arial" pitchFamily="34" charset="0"/>
-                <a:ea typeface="Arial" pitchFamily="34" charset="-122"/>
-                <a:cs typeface="Arial" pitchFamily="34" charset="-120"/>
-              </a:rPr>
-              <a:t>autónoma</a:t>
-            </a:r>
-            <a:r>
-              <a:rPr lang="en-US" sz="1676" b="1" dirty="0">
-                <a:solidFill>
-                  <a:srgbClr val="585E6F"/>
-                </a:solidFill>
-                <a:latin typeface="Arial" pitchFamily="34" charset="0"/>
-                <a:ea typeface="Arial" pitchFamily="34" charset="-122"/>
-                <a:cs typeface="Arial" pitchFamily="34" charset="-120"/>
-              </a:rPr>
-              <a:t> </a:t>
-            </a:r>
-            <a:r>
-              <a:rPr lang="en-US" sz="1676" b="1" dirty="0" err="1">
-                <a:solidFill>
-                  <a:srgbClr val="585E6F"/>
-                </a:solidFill>
-                <a:latin typeface="Arial" pitchFamily="34" charset="0"/>
-                <a:ea typeface="Arial" pitchFamily="34" charset="-122"/>
-                <a:cs typeface="Arial" pitchFamily="34" charset="-120"/>
-              </a:rPr>
-              <a:t>simulando</a:t>
-            </a:r>
-            <a:r>
-              <a:rPr lang="en-US" sz="1676" b="1" dirty="0">
-                <a:solidFill>
-                  <a:srgbClr val="585E6F"/>
-                </a:solidFill>
-                <a:latin typeface="Arial" pitchFamily="34" charset="0"/>
-                <a:ea typeface="Arial" pitchFamily="34" charset="-122"/>
-                <a:cs typeface="Arial" pitchFamily="34" charset="-120"/>
-              </a:rPr>
-              <a:t> a un </a:t>
-            </a:r>
-            <a:r>
-              <a:rPr lang="en-US" sz="1676" b="1" dirty="0" err="1">
-                <a:solidFill>
-                  <a:srgbClr val="585E6F"/>
-                </a:solidFill>
-                <a:latin typeface="Arial" pitchFamily="34" charset="0"/>
-                <a:ea typeface="Arial" pitchFamily="34" charset="-122"/>
-                <a:cs typeface="Arial" pitchFamily="34" charset="-120"/>
-              </a:rPr>
-              <a:t>humano</a:t>
-            </a:r>
-            <a:endParaRPr lang="en-US" sz="1676" b="1" dirty="0">
-              <a:solidFill>
-                <a:srgbClr val="585E6F"/>
-              </a:solidFill>
-              <a:latin typeface="Arial" pitchFamily="34" charset="0"/>
-              <a:ea typeface="Arial" pitchFamily="34" charset="-122"/>
-              <a:cs typeface="Arial" pitchFamily="34" charset="-120"/>
-            </a:endParaRPr>
-          </a:p>
-          <a:p>
-            <a:pPr marL="0" indent="0" algn="l">
-              <a:lnSpc>
-                <a:spcPts val="2430"/>
-              </a:lnSpc>
-              <a:buNone/>
-            </a:pPr>
-            <a:r>
-              <a:rPr lang="en-US" sz="1676" b="1" dirty="0" err="1">
-                <a:solidFill>
-                  <a:srgbClr val="585E6F"/>
-                </a:solidFill>
-                <a:latin typeface="Arial" pitchFamily="34" charset="0"/>
-                <a:ea typeface="Arial" pitchFamily="34" charset="-122"/>
-                <a:cs typeface="Arial" pitchFamily="34" charset="-120"/>
-              </a:rPr>
-              <a:t>en</a:t>
-            </a:r>
-            <a:r>
-              <a:rPr lang="en-US" sz="1676" b="1" dirty="0">
-                <a:solidFill>
-                  <a:srgbClr val="585E6F"/>
-                </a:solidFill>
-                <a:latin typeface="Arial" pitchFamily="34" charset="0"/>
-                <a:ea typeface="Arial" pitchFamily="34" charset="-122"/>
-                <a:cs typeface="Arial" pitchFamily="34" charset="-120"/>
-              </a:rPr>
-              <a:t> la </a:t>
-            </a:r>
-            <a:r>
-              <a:rPr lang="en-US" sz="1676" b="1" dirty="0" err="1">
-                <a:solidFill>
-                  <a:srgbClr val="585E6F"/>
-                </a:solidFill>
-                <a:latin typeface="Arial" pitchFamily="34" charset="0"/>
-                <a:ea typeface="Arial" pitchFamily="34" charset="-122"/>
-                <a:cs typeface="Arial" pitchFamily="34" charset="-120"/>
-              </a:rPr>
-              <a:t>ejecución</a:t>
-            </a:r>
-            <a:r>
-              <a:rPr lang="en-US" sz="1676" b="1" dirty="0">
-                <a:solidFill>
-                  <a:srgbClr val="585E6F"/>
-                </a:solidFill>
-                <a:latin typeface="Arial" pitchFamily="34" charset="0"/>
-                <a:ea typeface="Arial" pitchFamily="34" charset="-122"/>
-                <a:cs typeface="Arial" pitchFamily="34" charset="-120"/>
-              </a:rPr>
-              <a:t> de </a:t>
-            </a:r>
-            <a:r>
-              <a:rPr lang="en-US" sz="1676" b="1" dirty="0" err="1">
-                <a:solidFill>
-                  <a:srgbClr val="585E6F"/>
-                </a:solidFill>
-                <a:latin typeface="Arial" pitchFamily="34" charset="0"/>
-                <a:ea typeface="Arial" pitchFamily="34" charset="-122"/>
-                <a:cs typeface="Arial" pitchFamily="34" charset="-120"/>
-              </a:rPr>
-              <a:t>una</a:t>
-            </a:r>
-            <a:r>
-              <a:rPr lang="en-US" sz="1676" b="1" dirty="0">
-                <a:solidFill>
-                  <a:srgbClr val="585E6F"/>
-                </a:solidFill>
-                <a:latin typeface="Arial" pitchFamily="34" charset="0"/>
-                <a:ea typeface="Arial" pitchFamily="34" charset="-122"/>
-                <a:cs typeface="Arial" pitchFamily="34" charset="-120"/>
-              </a:rPr>
-              <a:t> o </a:t>
-            </a:r>
-            <a:r>
-              <a:rPr lang="en-US" sz="1676" b="1" dirty="0" err="1">
-                <a:solidFill>
-                  <a:srgbClr val="585E6F"/>
-                </a:solidFill>
-                <a:latin typeface="Arial" pitchFamily="34" charset="0"/>
-                <a:ea typeface="Arial" pitchFamily="34" charset="-122"/>
-                <a:cs typeface="Arial" pitchFamily="34" charset="-120"/>
-              </a:rPr>
-              <a:t>varias</a:t>
-            </a:r>
-            <a:r>
-              <a:rPr lang="en-US" sz="1676" b="1" dirty="0">
-                <a:solidFill>
-                  <a:srgbClr val="585E6F"/>
-                </a:solidFill>
-                <a:latin typeface="Arial" pitchFamily="34" charset="0"/>
-                <a:ea typeface="Arial" pitchFamily="34" charset="-122"/>
-                <a:cs typeface="Arial" pitchFamily="34" charset="-120"/>
-              </a:rPr>
-              <a:t> </a:t>
-            </a:r>
-            <a:r>
-              <a:rPr lang="en-US" sz="1676" b="1" dirty="0" err="1">
-                <a:solidFill>
-                  <a:srgbClr val="585E6F"/>
-                </a:solidFill>
-                <a:latin typeface="Arial" pitchFamily="34" charset="0"/>
-                <a:ea typeface="Arial" pitchFamily="34" charset="-122"/>
-                <a:cs typeface="Arial" pitchFamily="34" charset="-120"/>
-              </a:rPr>
-              <a:t>tareas</a:t>
-            </a:r>
-            <a:r>
-              <a:rPr lang="en-US" sz="1676" b="1" dirty="0">
-                <a:solidFill>
-                  <a:srgbClr val="585E6F"/>
-                </a:solidFill>
-                <a:latin typeface="Arial" pitchFamily="34" charset="0"/>
-                <a:ea typeface="Arial" pitchFamily="34" charset="-122"/>
-                <a:cs typeface="Arial" pitchFamily="34" charset="-120"/>
-              </a:rPr>
-              <a:t>.  </a:t>
-            </a:r>
-            <a:endParaRPr lang="en-US" sz="1676" b="1" dirty="0"/>
+              <a:t>Módulo 3 · Construcción de sistemas agénticos</a:t>
+            </a:r>
+            <a:endParaRPr lang="en-US" sz="1080" dirty="0"/>
+          </a:p>
+        </p:txBody>
+      </p:sp>
+      <p:sp>
+        <p:nvSpPr>
+          <p:cNvPr id="37" name="s16-forma-36"/>
+          <p:cNvSpPr/>
+          <p:nvPr/>
+        </p:nvSpPr>
+        <p:spPr>
+          <a:xfrm>
+            <a:off x="853390" y="6411138"/>
+            <a:ext cx="10484915" cy="5713"/>
+          </a:xfrm>
+          <a:prstGeom prst="rect">
+            <a:avLst/>
+          </a:prstGeom>
+          <a:solidFill>
+            <a:srgbClr val="DBD4C4"/>
+          </a:solidFill>
+          <a:ln/>
+        </p:spPr>
+        <p:txBody>
+          <a:bodyPr/>
+          <a:lstStyle/>
+          <a:p>
+            <a:endParaRPr lang="es-MX"/>
           </a:p>
         </p:txBody>
       </p:sp>
       <p:pic>
         <p:nvPicPr>
-          <p:cNvPr id="9" name="s10-logo-8" descr="preencoded.png"/>
+          <p:cNvPr id="38" name="s16-logo-37" descr="preencoded.png"/>
           <p:cNvPicPr>
             <a:picLocks noChangeAspect="1"/>
           </p:cNvPicPr>
@@ -10602,7 +10256,7 @@
       </p:pic>
       <p:sp>
         <p:nvSpPr>
-          <p:cNvPr id="10" name="s10-forma-9"/>
+          <p:cNvPr id="39" name="s16-forma-38"/>
           <p:cNvSpPr/>
           <p:nvPr/>
         </p:nvSpPr>
@@ -10626,7 +10280,7 @@
       </p:sp>
       <p:sp>
         <p:nvSpPr>
-          <p:cNvPr id="11" name="s10-forma-10"/>
+          <p:cNvPr id="40" name="s16-forma-39"/>
           <p:cNvSpPr/>
           <p:nvPr/>
         </p:nvSpPr>
@@ -10653,7 +10307,7 @@
       </p:sp>
       <p:sp>
         <p:nvSpPr>
-          <p:cNvPr id="12" name="s10-texto-11"/>
+          <p:cNvPr id="41" name="s16-texto-40"/>
           <p:cNvSpPr txBox="1"/>
           <p:nvPr/>
         </p:nvSpPr>
@@ -10687,7 +10341,7 @@
                 <a:ea typeface="Courier New" pitchFamily="34" charset="-122"/>
                 <a:cs typeface="Courier New" pitchFamily="34" charset="-120"/>
               </a:rPr>
-              <a:t>MÓDULO 3 · SESIÓN 1 — ARQUITECTURA DE AGENTES</a:t>
+              <a:t>MÓDULO 3 · CONSTRUCCIÓN DE SISTEMAS AGÉNTICOS</a:t>
             </a:r>
             <a:endParaRPr lang="en-US" sz="704" dirty="0"/>
           </a:p>
@@ -10695,7 +10349,7 @@
       </p:sp>
       <p:sp>
         <p:nvSpPr>
-          <p:cNvPr id="13" name="s10-texto-12"/>
+          <p:cNvPr id="42" name="s16-texto-41"/>
           <p:cNvSpPr txBox="1"/>
           <p:nvPr/>
         </p:nvSpPr>
@@ -10720,31 +10374,20 @@
               </a:lnSpc>
               <a:buNone/>
             </a:pPr>
-            <a:r>
-              <a:rPr lang="en-US" sz="745" kern="0" spc="74" dirty="0">
-                <a:solidFill>
-                  <a:srgbClr val="585E6F"/>
-                </a:solidFill>
-                <a:latin typeface="Courier New" pitchFamily="34" charset="0"/>
-                <a:ea typeface="Courier New" pitchFamily="34" charset="-122"/>
-                <a:cs typeface="Courier New" pitchFamily="34" charset="-120"/>
-              </a:rPr>
-              <a:t>10 / 35</a:t>
-            </a:r>
             <a:endParaRPr lang="en-US" sz="745" dirty="0"/>
           </a:p>
         </p:txBody>
       </p:sp>
       <p:sp>
         <p:nvSpPr>
-          <p:cNvPr id="14" name="s10-forma-13"/>
+          <p:cNvPr id="43" name="s16-forma-42"/>
           <p:cNvSpPr/>
           <p:nvPr/>
         </p:nvSpPr>
         <p:spPr>
           <a:xfrm>
             <a:off x="0" y="0"/>
-            <a:ext cx="3483278" cy="17139"/>
+            <a:ext cx="5573280" cy="17139"/>
           </a:xfrm>
           <a:prstGeom prst="rect">
             <a:avLst/>
@@ -10759,6 +10402,2059 @@
           <a:lstStyle/>
           <a:p>
             <a:endParaRPr lang="es-MX"/>
+          </a:p>
+        </p:txBody>
+      </p:sp>
+      <p:sp>
+        <p:nvSpPr>
+          <p:cNvPr id="44" name="Rectangle 43"/>
+          <p:cNvSpPr/>
+          <p:nvPr/>
+        </p:nvSpPr>
+        <p:spPr>
+          <a:xfrm>
+            <a:off x="1344168" y="2103120"/>
+            <a:ext cx="10058400" cy="749808"/>
+          </a:xfrm>
+          <a:prstGeom prst="rect">
+            <a:avLst/>
+          </a:prstGeom>
+          <a:solidFill>
+            <a:srgbClr val="E3DCCB"/>
+          </a:solidFill>
+          <a:ln>
+            <a:noFill/>
+          </a:ln>
+          <a:effectLst/>
+        </p:spPr>
+        <p:style>
+          <a:lnRef idx="1">
+            <a:schemeClr val="accent1"/>
+          </a:lnRef>
+          <a:fillRef idx="3">
+            <a:schemeClr val="accent1"/>
+          </a:fillRef>
+          <a:effectRef idx="2">
+            <a:schemeClr val="accent1"/>
+          </a:effectRef>
+          <a:fontRef idx="minor">
+            <a:schemeClr val="lt1"/>
+          </a:fontRef>
+        </p:style>
+        <p:txBody>
+          <a:bodyPr rtlCol="0" anchor="ctr"/>
+          <a:lstStyle/>
+          <a:p>
+            <a:pPr algn="ctr"/>
+            <a:endParaRPr/>
+          </a:p>
+        </p:txBody>
+      </p:sp>
+      <p:sp>
+        <p:nvSpPr>
+          <p:cNvPr id="45" name="Rectangle 44"/>
+          <p:cNvSpPr/>
+          <p:nvPr/>
+        </p:nvSpPr>
+        <p:spPr>
+          <a:xfrm>
+            <a:off x="1344168" y="2103120"/>
+            <a:ext cx="54864" cy="749808"/>
+          </a:xfrm>
+          <a:prstGeom prst="rect">
+            <a:avLst/>
+          </a:prstGeom>
+          <a:solidFill>
+            <a:srgbClr val="984514"/>
+          </a:solidFill>
+          <a:ln>
+            <a:noFill/>
+          </a:ln>
+          <a:effectLst/>
+        </p:spPr>
+        <p:style>
+          <a:lnRef idx="1">
+            <a:schemeClr val="accent1"/>
+          </a:lnRef>
+          <a:fillRef idx="3">
+            <a:schemeClr val="accent1"/>
+          </a:fillRef>
+          <a:effectRef idx="2">
+            <a:schemeClr val="accent1"/>
+          </a:effectRef>
+          <a:fontRef idx="minor">
+            <a:schemeClr val="lt1"/>
+          </a:fontRef>
+        </p:style>
+        <p:txBody>
+          <a:bodyPr rtlCol="0" anchor="ctr"/>
+          <a:lstStyle/>
+          <a:p>
+            <a:pPr algn="ctr"/>
+            <a:endParaRPr/>
+          </a:p>
+        </p:txBody>
+      </p:sp>
+      <p:sp>
+        <p:nvSpPr>
+          <p:cNvPr id="46" name="TextBox 45"/>
+          <p:cNvSpPr txBox="1"/>
+          <p:nvPr/>
+        </p:nvSpPr>
+        <p:spPr>
+          <a:xfrm>
+            <a:off x="1600200" y="2103120"/>
+            <a:ext cx="9692640" cy="749808"/>
+          </a:xfrm>
+          <a:prstGeom prst="rect">
+            <a:avLst/>
+          </a:prstGeom>
+          <a:noFill/>
+        </p:spPr>
+        <p:txBody>
+          <a:bodyPr wrap="square" lIns="0" tIns="0" rIns="0" bIns="0" anchor="ctr">
+            <a:spAutoFit/>
+          </a:bodyPr>
+          <a:lstStyle/>
+          <a:p>
+            <a:pPr algn="l"/>
+            <a:r>
+              <a:rPr sz="1500" b="0" i="0">
+                <a:solidFill>
+                  <a:srgbClr val="16181D"/>
+                </a:solidFill>
+                <a:latin typeface="Georgia"/>
+              </a:rPr>
+              <a:t>Un componente de software cuyo objetivo es </a:t>
+            </a:r>
+            <a:r>
+              <a:rPr sz="1500" b="1" i="0">
+                <a:solidFill>
+                  <a:srgbClr val="0033A0"/>
+                </a:solidFill>
+                <a:latin typeface="Georgia"/>
+              </a:rPr>
+              <a:t>actuar de forma autónoma</a:t>
+            </a:r>
+            <a:r>
+              <a:rPr sz="1500" b="0" i="0">
+                <a:solidFill>
+                  <a:srgbClr val="16181D"/>
+                </a:solidFill>
+                <a:latin typeface="Georgia"/>
+              </a:rPr>
+              <a:t> simulando a un humano en la ejecución de una o varias tareas.</a:t>
+            </a:r>
+          </a:p>
+        </p:txBody>
+      </p:sp>
+      <p:sp>
+        <p:nvSpPr>
+          <p:cNvPr id="47" name="Rectangle 46"/>
+          <p:cNvSpPr/>
+          <p:nvPr/>
+        </p:nvSpPr>
+        <p:spPr>
+          <a:xfrm>
+            <a:off x="1344168" y="3017520"/>
+            <a:ext cx="3230880" cy="2395728"/>
+          </a:xfrm>
+          <a:prstGeom prst="rect">
+            <a:avLst/>
+          </a:prstGeom>
+          <a:noFill/>
+          <a:ln w="9525">
+            <a:solidFill>
+              <a:srgbClr val="C6BFAE"/>
+            </a:solidFill>
+          </a:ln>
+          <a:effectLst/>
+        </p:spPr>
+        <p:style>
+          <a:lnRef idx="1">
+            <a:schemeClr val="accent1"/>
+          </a:lnRef>
+          <a:fillRef idx="3">
+            <a:schemeClr val="accent1"/>
+          </a:fillRef>
+          <a:effectRef idx="2">
+            <a:schemeClr val="accent1"/>
+          </a:effectRef>
+          <a:fontRef idx="minor">
+            <a:schemeClr val="lt1"/>
+          </a:fontRef>
+        </p:style>
+        <p:txBody>
+          <a:bodyPr rtlCol="0" anchor="ctr"/>
+          <a:lstStyle/>
+          <a:p>
+            <a:pPr algn="ctr"/>
+            <a:endParaRPr/>
+          </a:p>
+        </p:txBody>
+      </p:sp>
+      <p:sp>
+        <p:nvSpPr>
+          <p:cNvPr id="48" name="TextBox 47"/>
+          <p:cNvSpPr txBox="1"/>
+          <p:nvPr/>
+        </p:nvSpPr>
+        <p:spPr>
+          <a:xfrm>
+            <a:off x="1490472" y="3108960"/>
+            <a:ext cx="365760" cy="457200"/>
+          </a:xfrm>
+          <a:prstGeom prst="rect">
+            <a:avLst/>
+          </a:prstGeom>
+          <a:noFill/>
+        </p:spPr>
+        <p:txBody>
+          <a:bodyPr wrap="square" lIns="0" tIns="0" rIns="0" bIns="0" anchor="t">
+            <a:spAutoFit/>
+          </a:bodyPr>
+          <a:lstStyle/>
+          <a:p>
+            <a:pPr algn="l"/>
+            <a:r>
+              <a:rPr sz="2200" b="1" i="0">
+                <a:solidFill>
+                  <a:srgbClr val="984514"/>
+                </a:solidFill>
+                <a:latin typeface="Georgia"/>
+              </a:rPr>
+              <a:t>1</a:t>
+            </a:r>
+          </a:p>
+        </p:txBody>
+      </p:sp>
+      <p:sp>
+        <p:nvSpPr>
+          <p:cNvPr id="49" name="TextBox 48"/>
+          <p:cNvSpPr txBox="1"/>
+          <p:nvPr/>
+        </p:nvSpPr>
+        <p:spPr>
+          <a:xfrm>
+            <a:off x="1874519" y="3145536"/>
+            <a:ext cx="2590799" cy="457200"/>
+          </a:xfrm>
+          <a:prstGeom prst="rect">
+            <a:avLst/>
+          </a:prstGeom>
+          <a:noFill/>
+        </p:spPr>
+        <p:txBody>
+          <a:bodyPr wrap="square" lIns="0" tIns="0" rIns="0" bIns="0" anchor="t">
+            <a:spAutoFit/>
+          </a:bodyPr>
+          <a:lstStyle/>
+          <a:p>
+            <a:pPr algn="l">
+              <a:lnSpc>
+                <a:spcPct val="100000"/>
+              </a:lnSpc>
+            </a:pPr>
+            <a:r>
+              <a:rPr sz="1250" b="1" i="0">
+                <a:solidFill>
+                  <a:srgbClr val="16181D"/>
+                </a:solidFill>
+                <a:latin typeface="Arial"/>
+              </a:rPr>
+              <a:t>Se comunica</a:t>
+            </a:r>
+          </a:p>
+          <a:p>
+            <a:pPr algn="l">
+              <a:lnSpc>
+                <a:spcPct val="100000"/>
+              </a:lnSpc>
+            </a:pPr>
+            <a:r>
+              <a:rPr sz="850" b="0" i="1">
+                <a:solidFill>
+                  <a:srgbClr val="0033A0"/>
+                </a:solidFill>
+                <a:latin typeface="Arial"/>
+              </a:rPr>
+              <a:t>en lenguaje natural</a:t>
+            </a:r>
+          </a:p>
+        </p:txBody>
+      </p:sp>
+      <p:sp>
+        <p:nvSpPr>
+          <p:cNvPr id="50" name="TextBox 49"/>
+          <p:cNvSpPr txBox="1"/>
+          <p:nvPr/>
+        </p:nvSpPr>
+        <p:spPr>
+          <a:xfrm>
+            <a:off x="1490472" y="3621024"/>
+            <a:ext cx="2938272" cy="411480"/>
+          </a:xfrm>
+          <a:prstGeom prst="rect">
+            <a:avLst/>
+          </a:prstGeom>
+          <a:noFill/>
+        </p:spPr>
+        <p:txBody>
+          <a:bodyPr wrap="square" lIns="0" tIns="0" rIns="0" bIns="0" anchor="t">
+            <a:spAutoFit/>
+          </a:bodyPr>
+          <a:lstStyle/>
+          <a:p>
+            <a:pPr algn="l"/>
+            <a:r>
+              <a:rPr sz="880" b="0" i="0">
+                <a:solidFill>
+                  <a:srgbClr val="585E6F"/>
+                </a:solidFill>
+                <a:latin typeface="Arial"/>
+              </a:rPr>
+              <a:t>Entiende lo que le pides y te responde con palabras, no con formularios ni comandos.</a:t>
+            </a:r>
+          </a:p>
+        </p:txBody>
+      </p:sp>
+      <p:sp>
+        <p:nvSpPr>
+          <p:cNvPr id="51" name="Rounded Rectangle 50"/>
+          <p:cNvSpPr/>
+          <p:nvPr/>
+        </p:nvSpPr>
+        <p:spPr>
+          <a:xfrm>
+            <a:off x="1527048" y="4096511"/>
+            <a:ext cx="2011680" cy="310896"/>
+          </a:xfrm>
+          <a:prstGeom prst="roundRect">
+            <a:avLst>
+              <a:gd name="adj" fmla="val 50000"/>
+            </a:avLst>
+          </a:prstGeom>
+          <a:solidFill>
+            <a:srgbClr val="FBF8F0"/>
+          </a:solidFill>
+          <a:ln w="9525">
+            <a:solidFill>
+              <a:srgbClr val="C6BFAE"/>
+            </a:solidFill>
+          </a:ln>
+          <a:effectLst/>
+        </p:spPr>
+        <p:style>
+          <a:lnRef idx="1">
+            <a:schemeClr val="accent1"/>
+          </a:lnRef>
+          <a:fillRef idx="3">
+            <a:schemeClr val="accent1"/>
+          </a:fillRef>
+          <a:effectRef idx="2">
+            <a:schemeClr val="accent1"/>
+          </a:effectRef>
+          <a:fontRef idx="minor">
+            <a:schemeClr val="lt1"/>
+          </a:fontRef>
+        </p:style>
+        <p:txBody>
+          <a:bodyPr rtlCol="0" anchor="ctr"/>
+          <a:lstStyle/>
+          <a:p>
+            <a:pPr algn="ctr"/>
+            <a:endParaRPr/>
+          </a:p>
+        </p:txBody>
+      </p:sp>
+      <p:sp>
+        <p:nvSpPr>
+          <p:cNvPr id="52" name="TextBox 51"/>
+          <p:cNvSpPr txBox="1"/>
+          <p:nvPr/>
+        </p:nvSpPr>
+        <p:spPr>
+          <a:xfrm>
+            <a:off x="1618488" y="4096511"/>
+            <a:ext cx="1874519" cy="310896"/>
+          </a:xfrm>
+          <a:prstGeom prst="rect">
+            <a:avLst/>
+          </a:prstGeom>
+          <a:noFill/>
+        </p:spPr>
+        <p:txBody>
+          <a:bodyPr wrap="square" lIns="0" tIns="0" rIns="0" bIns="0" anchor="ctr">
+            <a:spAutoFit/>
+          </a:bodyPr>
+          <a:lstStyle/>
+          <a:p>
+            <a:pPr algn="l"/>
+            <a:r>
+              <a:rPr sz="800" b="0" i="0">
+                <a:solidFill>
+                  <a:srgbClr val="16181D"/>
+                </a:solidFill>
+                <a:latin typeface="Arial"/>
+              </a:rPr>
+              <a:t>Tú: «Da de alta a Ana en Ventas»</a:t>
+            </a:r>
+          </a:p>
+        </p:txBody>
+      </p:sp>
+      <p:sp>
+        <p:nvSpPr>
+          <p:cNvPr id="53" name="Rounded Rectangle 52"/>
+          <p:cNvSpPr/>
+          <p:nvPr/>
+        </p:nvSpPr>
+        <p:spPr>
+          <a:xfrm>
+            <a:off x="2362199" y="4498848"/>
+            <a:ext cx="2029968" cy="310896"/>
+          </a:xfrm>
+          <a:prstGeom prst="roundRect">
+            <a:avLst>
+              <a:gd name="adj" fmla="val 50000"/>
+            </a:avLst>
+          </a:prstGeom>
+          <a:solidFill>
+            <a:srgbClr val="DDE4F2"/>
+          </a:solidFill>
+          <a:ln w="11430">
+            <a:solidFill>
+              <a:srgbClr val="0033A0"/>
+            </a:solidFill>
+          </a:ln>
+          <a:effectLst/>
+        </p:spPr>
+        <p:style>
+          <a:lnRef idx="1">
+            <a:schemeClr val="accent1"/>
+          </a:lnRef>
+          <a:fillRef idx="3">
+            <a:schemeClr val="accent1"/>
+          </a:fillRef>
+          <a:effectRef idx="2">
+            <a:schemeClr val="accent1"/>
+          </a:effectRef>
+          <a:fontRef idx="minor">
+            <a:schemeClr val="lt1"/>
+          </a:fontRef>
+        </p:style>
+        <p:txBody>
+          <a:bodyPr rtlCol="0" anchor="ctr"/>
+          <a:lstStyle/>
+          <a:p>
+            <a:pPr algn="ctr"/>
+            <a:endParaRPr/>
+          </a:p>
+        </p:txBody>
+      </p:sp>
+      <p:sp>
+        <p:nvSpPr>
+          <p:cNvPr id="54" name="TextBox 53"/>
+          <p:cNvSpPr txBox="1"/>
+          <p:nvPr/>
+        </p:nvSpPr>
+        <p:spPr>
+          <a:xfrm>
+            <a:off x="2435352" y="4498848"/>
+            <a:ext cx="1920240" cy="310896"/>
+          </a:xfrm>
+          <a:prstGeom prst="rect">
+            <a:avLst/>
+          </a:prstGeom>
+          <a:noFill/>
+        </p:spPr>
+        <p:txBody>
+          <a:bodyPr wrap="square" lIns="0" tIns="0" rIns="0" bIns="0" anchor="ctr">
+            <a:spAutoFit/>
+          </a:bodyPr>
+          <a:lstStyle/>
+          <a:p>
+            <a:pPr algn="l"/>
+            <a:r>
+              <a:rPr sz="800" b="1" i="0">
+                <a:solidFill>
+                  <a:srgbClr val="0033A0"/>
+                </a:solidFill>
+                <a:latin typeface="Arial"/>
+              </a:rPr>
+              <a:t>Agente: «Listo, es EMP-0012»</a:t>
+            </a:r>
+          </a:p>
+        </p:txBody>
+      </p:sp>
+      <p:sp>
+        <p:nvSpPr>
+          <p:cNvPr id="55" name="Rectangle 54"/>
+          <p:cNvSpPr/>
+          <p:nvPr/>
+        </p:nvSpPr>
+        <p:spPr>
+          <a:xfrm>
+            <a:off x="1490472" y="5001768"/>
+            <a:ext cx="2938272" cy="301752"/>
+          </a:xfrm>
+          <a:prstGeom prst="rect">
+            <a:avLst/>
+          </a:prstGeom>
+          <a:solidFill>
+            <a:srgbClr val="E6DFCF"/>
+          </a:solidFill>
+          <a:ln>
+            <a:noFill/>
+          </a:ln>
+          <a:effectLst/>
+        </p:spPr>
+        <p:style>
+          <a:lnRef idx="1">
+            <a:schemeClr val="accent1"/>
+          </a:lnRef>
+          <a:fillRef idx="3">
+            <a:schemeClr val="accent1"/>
+          </a:fillRef>
+          <a:effectRef idx="2">
+            <a:schemeClr val="accent1"/>
+          </a:effectRef>
+          <a:fontRef idx="minor">
+            <a:schemeClr val="lt1"/>
+          </a:fontRef>
+        </p:style>
+        <p:txBody>
+          <a:bodyPr rtlCol="0" anchor="ctr"/>
+          <a:lstStyle/>
+          <a:p>
+            <a:pPr algn="ctr"/>
+            <a:endParaRPr/>
+          </a:p>
+        </p:txBody>
+      </p:sp>
+      <p:sp>
+        <p:nvSpPr>
+          <p:cNvPr id="56" name="TextBox 55"/>
+          <p:cNvSpPr txBox="1"/>
+          <p:nvPr/>
+        </p:nvSpPr>
+        <p:spPr>
+          <a:xfrm>
+            <a:off x="1563624" y="5001768"/>
+            <a:ext cx="2865120" cy="301752"/>
+          </a:xfrm>
+          <a:prstGeom prst="rect">
+            <a:avLst/>
+          </a:prstGeom>
+          <a:noFill/>
+        </p:spPr>
+        <p:txBody>
+          <a:bodyPr wrap="square" lIns="0" tIns="0" rIns="0" bIns="0" anchor="ctr">
+            <a:spAutoFit/>
+          </a:bodyPr>
+          <a:lstStyle/>
+          <a:p>
+            <a:pPr algn="l"/>
+            <a:r>
+              <a:rPr sz="830" b="1" i="0">
+                <a:solidFill>
+                  <a:srgbClr val="16181D"/>
+                </a:solidFill>
+                <a:latin typeface="Arial"/>
+              </a:rPr>
+              <a:t>Como un humano: </a:t>
+            </a:r>
+            <a:r>
+              <a:rPr sz="830" b="0" i="0">
+                <a:solidFill>
+                  <a:srgbClr val="585E6F"/>
+                </a:solidFill>
+                <a:latin typeface="Arial"/>
+              </a:rPr>
+              <a:t>como un colega al que le explicas un encargo</a:t>
+            </a:r>
+          </a:p>
+        </p:txBody>
+      </p:sp>
+      <p:sp>
+        <p:nvSpPr>
+          <p:cNvPr id="57" name="Rectangle 56"/>
+          <p:cNvSpPr/>
+          <p:nvPr/>
+        </p:nvSpPr>
+        <p:spPr>
+          <a:xfrm>
+            <a:off x="4757928" y="3017520"/>
+            <a:ext cx="3230880" cy="2395728"/>
+          </a:xfrm>
+          <a:prstGeom prst="rect">
+            <a:avLst/>
+          </a:prstGeom>
+          <a:noFill/>
+          <a:ln w="9525">
+            <a:solidFill>
+              <a:srgbClr val="C6BFAE"/>
+            </a:solidFill>
+          </a:ln>
+          <a:effectLst/>
+        </p:spPr>
+        <p:style>
+          <a:lnRef idx="1">
+            <a:schemeClr val="accent1"/>
+          </a:lnRef>
+          <a:fillRef idx="3">
+            <a:schemeClr val="accent1"/>
+          </a:fillRef>
+          <a:effectRef idx="2">
+            <a:schemeClr val="accent1"/>
+          </a:effectRef>
+          <a:fontRef idx="minor">
+            <a:schemeClr val="lt1"/>
+          </a:fontRef>
+        </p:style>
+        <p:txBody>
+          <a:bodyPr rtlCol="0" anchor="ctr"/>
+          <a:lstStyle/>
+          <a:p>
+            <a:pPr algn="ctr"/>
+            <a:endParaRPr/>
+          </a:p>
+        </p:txBody>
+      </p:sp>
+      <p:sp>
+        <p:nvSpPr>
+          <p:cNvPr id="58" name="TextBox 57"/>
+          <p:cNvSpPr txBox="1"/>
+          <p:nvPr/>
+        </p:nvSpPr>
+        <p:spPr>
+          <a:xfrm>
+            <a:off x="4904232" y="3108960"/>
+            <a:ext cx="365760" cy="457200"/>
+          </a:xfrm>
+          <a:prstGeom prst="rect">
+            <a:avLst/>
+          </a:prstGeom>
+          <a:noFill/>
+        </p:spPr>
+        <p:txBody>
+          <a:bodyPr wrap="square" lIns="0" tIns="0" rIns="0" bIns="0" anchor="t">
+            <a:spAutoFit/>
+          </a:bodyPr>
+          <a:lstStyle/>
+          <a:p>
+            <a:pPr algn="l"/>
+            <a:r>
+              <a:rPr sz="2200" b="1" i="0">
+                <a:solidFill>
+                  <a:srgbClr val="984514"/>
+                </a:solidFill>
+                <a:latin typeface="Georgia"/>
+              </a:rPr>
+              <a:t>2</a:t>
+            </a:r>
+          </a:p>
+        </p:txBody>
+      </p:sp>
+      <p:sp>
+        <p:nvSpPr>
+          <p:cNvPr id="59" name="TextBox 58"/>
+          <p:cNvSpPr txBox="1"/>
+          <p:nvPr/>
+        </p:nvSpPr>
+        <p:spPr>
+          <a:xfrm>
+            <a:off x="5288280" y="3145536"/>
+            <a:ext cx="2590799" cy="457200"/>
+          </a:xfrm>
+          <a:prstGeom prst="rect">
+            <a:avLst/>
+          </a:prstGeom>
+          <a:noFill/>
+        </p:spPr>
+        <p:txBody>
+          <a:bodyPr wrap="square" lIns="0" tIns="0" rIns="0" bIns="0" anchor="t">
+            <a:spAutoFit/>
+          </a:bodyPr>
+          <a:lstStyle/>
+          <a:p>
+            <a:pPr algn="l">
+              <a:lnSpc>
+                <a:spcPct val="100000"/>
+              </a:lnSpc>
+            </a:pPr>
+            <a:r>
+              <a:rPr sz="1250" b="1" i="0">
+                <a:solidFill>
+                  <a:srgbClr val="16181D"/>
+                </a:solidFill>
+                <a:latin typeface="Arial"/>
+              </a:rPr>
+              <a:t>Elige y usa herramientas</a:t>
+            </a:r>
+          </a:p>
+          <a:p>
+            <a:pPr algn="l">
+              <a:lnSpc>
+                <a:spcPct val="100000"/>
+              </a:lnSpc>
+            </a:pPr>
+            <a:r>
+              <a:rPr sz="850" b="0" i="1">
+                <a:solidFill>
+                  <a:srgbClr val="0033A0"/>
+                </a:solidFill>
+                <a:latin typeface="Arial"/>
+              </a:rPr>
+              <a:t>la adecuada para cada paso</a:t>
+            </a:r>
+          </a:p>
+        </p:txBody>
+      </p:sp>
+      <p:sp>
+        <p:nvSpPr>
+          <p:cNvPr id="60" name="TextBox 59"/>
+          <p:cNvSpPr txBox="1"/>
+          <p:nvPr/>
+        </p:nvSpPr>
+        <p:spPr>
+          <a:xfrm>
+            <a:off x="4904232" y="3621024"/>
+            <a:ext cx="2938272" cy="411480"/>
+          </a:xfrm>
+          <a:prstGeom prst="rect">
+            <a:avLst/>
+          </a:prstGeom>
+          <a:noFill/>
+        </p:spPr>
+        <p:txBody>
+          <a:bodyPr wrap="square" lIns="0" tIns="0" rIns="0" bIns="0" anchor="t">
+            <a:spAutoFit/>
+          </a:bodyPr>
+          <a:lstStyle/>
+          <a:p>
+            <a:pPr algn="l"/>
+            <a:r>
+              <a:rPr sz="880" b="0" i="0">
+                <a:solidFill>
+                  <a:srgbClr val="585E6F"/>
+                </a:solidFill>
+                <a:latin typeface="Arial"/>
+              </a:rPr>
+              <a:t>Decide qué herramienta necesita (un archivo, un sistema, una prueba) y la usa.</a:t>
+            </a:r>
+          </a:p>
+        </p:txBody>
+      </p:sp>
+      <p:sp>
+        <p:nvSpPr>
+          <p:cNvPr id="61" name="Rectangle 60"/>
+          <p:cNvSpPr/>
+          <p:nvPr/>
+        </p:nvSpPr>
+        <p:spPr>
+          <a:xfrm>
+            <a:off x="4904232" y="4480559"/>
+            <a:ext cx="914400" cy="310896"/>
+          </a:xfrm>
+          <a:prstGeom prst="rect">
+            <a:avLst/>
+          </a:prstGeom>
+          <a:solidFill>
+            <a:srgbClr val="FBF8F0"/>
+          </a:solidFill>
+          <a:ln w="8890">
+            <a:solidFill>
+              <a:srgbClr val="C6BFAE"/>
+            </a:solidFill>
+          </a:ln>
+          <a:effectLst/>
+        </p:spPr>
+        <p:style>
+          <a:lnRef idx="1">
+            <a:schemeClr val="accent1"/>
+          </a:lnRef>
+          <a:fillRef idx="3">
+            <a:schemeClr val="accent1"/>
+          </a:fillRef>
+          <a:effectRef idx="2">
+            <a:schemeClr val="accent1"/>
+          </a:effectRef>
+          <a:fontRef idx="minor">
+            <a:schemeClr val="lt1"/>
+          </a:fontRef>
+        </p:style>
+        <p:txBody>
+          <a:bodyPr rtlCol="0" anchor="ctr"/>
+          <a:lstStyle/>
+          <a:p>
+            <a:pPr algn="ctr"/>
+            <a:endParaRPr/>
+          </a:p>
+        </p:txBody>
+      </p:sp>
+      <p:sp>
+        <p:nvSpPr>
+          <p:cNvPr id="62" name="TextBox 61"/>
+          <p:cNvSpPr txBox="1"/>
+          <p:nvPr/>
+        </p:nvSpPr>
+        <p:spPr>
+          <a:xfrm>
+            <a:off x="4904232" y="4480559"/>
+            <a:ext cx="914400" cy="310896"/>
+          </a:xfrm>
+          <a:prstGeom prst="rect">
+            <a:avLst/>
+          </a:prstGeom>
+          <a:noFill/>
+        </p:spPr>
+        <p:txBody>
+          <a:bodyPr wrap="square" lIns="0" tIns="0" rIns="0" bIns="0" anchor="ctr">
+            <a:spAutoFit/>
+          </a:bodyPr>
+          <a:lstStyle/>
+          <a:p>
+            <a:pPr algn="ctr"/>
+            <a:r>
+              <a:rPr sz="680" b="0" i="0">
+                <a:solidFill>
+                  <a:srgbClr val="585E6F"/>
+                </a:solidFill>
+                <a:latin typeface="Courier New"/>
+              </a:rPr>
+              <a:t>leer_archivo</a:t>
+            </a:r>
+          </a:p>
+        </p:txBody>
+      </p:sp>
+      <p:sp>
+        <p:nvSpPr>
+          <p:cNvPr id="63" name="Rectangle 62"/>
+          <p:cNvSpPr/>
+          <p:nvPr/>
+        </p:nvSpPr>
+        <p:spPr>
+          <a:xfrm>
+            <a:off x="5910072" y="4480559"/>
+            <a:ext cx="914400" cy="310896"/>
+          </a:xfrm>
+          <a:prstGeom prst="rect">
+            <a:avLst/>
+          </a:prstGeom>
+          <a:solidFill>
+            <a:srgbClr val="DDE4F2"/>
+          </a:solidFill>
+          <a:ln w="16510">
+            <a:solidFill>
+              <a:srgbClr val="0033A0"/>
+            </a:solidFill>
+          </a:ln>
+          <a:effectLst/>
+        </p:spPr>
+        <p:style>
+          <a:lnRef idx="1">
+            <a:schemeClr val="accent1"/>
+          </a:lnRef>
+          <a:fillRef idx="3">
+            <a:schemeClr val="accent1"/>
+          </a:fillRef>
+          <a:effectRef idx="2">
+            <a:schemeClr val="accent1"/>
+          </a:effectRef>
+          <a:fontRef idx="minor">
+            <a:schemeClr val="lt1"/>
+          </a:fontRef>
+        </p:style>
+        <p:txBody>
+          <a:bodyPr rtlCol="0" anchor="ctr"/>
+          <a:lstStyle/>
+          <a:p>
+            <a:pPr algn="ctr"/>
+            <a:endParaRPr/>
+          </a:p>
+        </p:txBody>
+      </p:sp>
+      <p:sp>
+        <p:nvSpPr>
+          <p:cNvPr id="64" name="TextBox 63"/>
+          <p:cNvSpPr txBox="1"/>
+          <p:nvPr/>
+        </p:nvSpPr>
+        <p:spPr>
+          <a:xfrm>
+            <a:off x="5910072" y="4480559"/>
+            <a:ext cx="914400" cy="310896"/>
+          </a:xfrm>
+          <a:prstGeom prst="rect">
+            <a:avLst/>
+          </a:prstGeom>
+          <a:noFill/>
+        </p:spPr>
+        <p:txBody>
+          <a:bodyPr wrap="square" lIns="0" tIns="0" rIns="0" bIns="0" anchor="ctr">
+            <a:spAutoFit/>
+          </a:bodyPr>
+          <a:lstStyle/>
+          <a:p>
+            <a:pPr algn="ctr"/>
+            <a:r>
+              <a:rPr sz="680" b="1" i="0">
+                <a:solidFill>
+                  <a:srgbClr val="0033A0"/>
+                </a:solidFill>
+                <a:latin typeface="Courier New"/>
+              </a:rPr>
+              <a:t>buscar_empleado</a:t>
+            </a:r>
+          </a:p>
+        </p:txBody>
+      </p:sp>
+      <p:sp>
+        <p:nvSpPr>
+          <p:cNvPr id="65" name="Rectangle 64"/>
+          <p:cNvSpPr/>
+          <p:nvPr/>
+        </p:nvSpPr>
+        <p:spPr>
+          <a:xfrm>
+            <a:off x="6915912" y="4480559"/>
+            <a:ext cx="914400" cy="310896"/>
+          </a:xfrm>
+          <a:prstGeom prst="rect">
+            <a:avLst/>
+          </a:prstGeom>
+          <a:solidFill>
+            <a:srgbClr val="FBF8F0"/>
+          </a:solidFill>
+          <a:ln w="8890">
+            <a:solidFill>
+              <a:srgbClr val="C6BFAE"/>
+            </a:solidFill>
+          </a:ln>
+          <a:effectLst/>
+        </p:spPr>
+        <p:style>
+          <a:lnRef idx="1">
+            <a:schemeClr val="accent1"/>
+          </a:lnRef>
+          <a:fillRef idx="3">
+            <a:schemeClr val="accent1"/>
+          </a:fillRef>
+          <a:effectRef idx="2">
+            <a:schemeClr val="accent1"/>
+          </a:effectRef>
+          <a:fontRef idx="minor">
+            <a:schemeClr val="lt1"/>
+          </a:fontRef>
+        </p:style>
+        <p:txBody>
+          <a:bodyPr rtlCol="0" anchor="ctr"/>
+          <a:lstStyle/>
+          <a:p>
+            <a:pPr algn="ctr"/>
+            <a:endParaRPr/>
+          </a:p>
+        </p:txBody>
+      </p:sp>
+      <p:sp>
+        <p:nvSpPr>
+          <p:cNvPr id="66" name="TextBox 65"/>
+          <p:cNvSpPr txBox="1"/>
+          <p:nvPr/>
+        </p:nvSpPr>
+        <p:spPr>
+          <a:xfrm>
+            <a:off x="6915912" y="4480559"/>
+            <a:ext cx="914400" cy="310896"/>
+          </a:xfrm>
+          <a:prstGeom prst="rect">
+            <a:avLst/>
+          </a:prstGeom>
+          <a:noFill/>
+        </p:spPr>
+        <p:txBody>
+          <a:bodyPr wrap="square" lIns="0" tIns="0" rIns="0" bIns="0" anchor="ctr">
+            <a:spAutoFit/>
+          </a:bodyPr>
+          <a:lstStyle/>
+          <a:p>
+            <a:pPr algn="ctr"/>
+            <a:r>
+              <a:rPr sz="680" b="0" i="0">
+                <a:solidFill>
+                  <a:srgbClr val="585E6F"/>
+                </a:solidFill>
+                <a:latin typeface="Courier New"/>
+              </a:rPr>
+              <a:t>correr_pruebas</a:t>
+            </a:r>
+          </a:p>
+        </p:txBody>
+      </p:sp>
+      <p:sp>
+        <p:nvSpPr>
+          <p:cNvPr id="67" name="TextBox 66"/>
+          <p:cNvSpPr txBox="1"/>
+          <p:nvPr/>
+        </p:nvSpPr>
+        <p:spPr>
+          <a:xfrm>
+            <a:off x="4904232" y="4096511"/>
+            <a:ext cx="2938272" cy="274320"/>
+          </a:xfrm>
+          <a:prstGeom prst="rect">
+            <a:avLst/>
+          </a:prstGeom>
+          <a:noFill/>
+        </p:spPr>
+        <p:txBody>
+          <a:bodyPr wrap="square" lIns="0" tIns="0" rIns="0" bIns="0" anchor="ctr">
+            <a:spAutoFit/>
+          </a:bodyPr>
+          <a:lstStyle/>
+          <a:p>
+            <a:pPr algn="ctr"/>
+            <a:r>
+              <a:rPr sz="800" b="0" i="0">
+                <a:solidFill>
+                  <a:srgbClr val="585E6F"/>
+                </a:solidFill>
+                <a:latin typeface="Arial"/>
+              </a:rPr>
+              <a:t>¿Qué necesito para este paso? → </a:t>
+            </a:r>
+            <a:r>
+              <a:rPr sz="800" b="1" i="0">
+                <a:solidFill>
+                  <a:srgbClr val="0033A0"/>
+                </a:solidFill>
+                <a:latin typeface="Arial"/>
+              </a:rPr>
+              <a:t>esta</a:t>
+            </a:r>
+          </a:p>
+        </p:txBody>
+      </p:sp>
+      <p:cxnSp>
+        <p:nvCxnSpPr>
+          <p:cNvPr id="68" name="Connector 67"/>
+          <p:cNvCxnSpPr/>
+          <p:nvPr/>
+        </p:nvCxnSpPr>
+        <p:spPr>
+          <a:xfrm>
+            <a:off x="6367272" y="4370831"/>
+            <a:ext cx="0" cy="109728"/>
+          </a:xfrm>
+          <a:prstGeom prst="line">
+            <a:avLst/>
+          </a:prstGeom>
+          <a:ln w="12700">
+            <a:solidFill>
+              <a:srgbClr val="0033A0"/>
+            </a:solidFill>
+            <a:tailEnd type="triangle" w="sm" len="sm"/>
+          </a:ln>
+        </p:spPr>
+        <p:style>
+          <a:lnRef idx="2">
+            <a:schemeClr val="accent1"/>
+          </a:lnRef>
+          <a:fillRef idx="0">
+            <a:schemeClr val="accent1"/>
+          </a:fillRef>
+          <a:effectRef idx="1">
+            <a:schemeClr val="accent1"/>
+          </a:effectRef>
+          <a:fontRef idx="minor">
+            <a:schemeClr val="tx1"/>
+          </a:fontRef>
+        </p:style>
+      </p:cxnSp>
+      <p:sp>
+        <p:nvSpPr>
+          <p:cNvPr id="69" name="Rectangle 68"/>
+          <p:cNvSpPr/>
+          <p:nvPr/>
+        </p:nvSpPr>
+        <p:spPr>
+          <a:xfrm>
+            <a:off x="4904232" y="5001768"/>
+            <a:ext cx="2938272" cy="301752"/>
+          </a:xfrm>
+          <a:prstGeom prst="rect">
+            <a:avLst/>
+          </a:prstGeom>
+          <a:solidFill>
+            <a:srgbClr val="E6DFCF"/>
+          </a:solidFill>
+          <a:ln>
+            <a:noFill/>
+          </a:ln>
+          <a:effectLst/>
+        </p:spPr>
+        <p:style>
+          <a:lnRef idx="1">
+            <a:schemeClr val="accent1"/>
+          </a:lnRef>
+          <a:fillRef idx="3">
+            <a:schemeClr val="accent1"/>
+          </a:fillRef>
+          <a:effectRef idx="2">
+            <a:schemeClr val="accent1"/>
+          </a:effectRef>
+          <a:fontRef idx="minor">
+            <a:schemeClr val="lt1"/>
+          </a:fontRef>
+        </p:style>
+        <p:txBody>
+          <a:bodyPr rtlCol="0" anchor="ctr"/>
+          <a:lstStyle/>
+          <a:p>
+            <a:pPr algn="ctr"/>
+            <a:endParaRPr/>
+          </a:p>
+        </p:txBody>
+      </p:sp>
+      <p:sp>
+        <p:nvSpPr>
+          <p:cNvPr id="70" name="TextBox 69"/>
+          <p:cNvSpPr txBox="1"/>
+          <p:nvPr/>
+        </p:nvSpPr>
+        <p:spPr>
+          <a:xfrm>
+            <a:off x="4977384" y="5001768"/>
+            <a:ext cx="2865120" cy="301752"/>
+          </a:xfrm>
+          <a:prstGeom prst="rect">
+            <a:avLst/>
+          </a:prstGeom>
+          <a:noFill/>
+        </p:spPr>
+        <p:txBody>
+          <a:bodyPr wrap="square" lIns="0" tIns="0" rIns="0" bIns="0" anchor="ctr">
+            <a:spAutoFit/>
+          </a:bodyPr>
+          <a:lstStyle/>
+          <a:p>
+            <a:pPr algn="l"/>
+            <a:r>
+              <a:rPr sz="830" b="1" i="0">
+                <a:solidFill>
+                  <a:srgbClr val="16181D"/>
+                </a:solidFill>
+                <a:latin typeface="Arial"/>
+              </a:rPr>
+              <a:t>Como un humano: </a:t>
+            </a:r>
+            <a:r>
+              <a:rPr sz="830" b="0" i="0">
+                <a:solidFill>
+                  <a:srgbClr val="585E6F"/>
+                </a:solidFill>
+                <a:latin typeface="Arial"/>
+              </a:rPr>
+              <a:t>como quien sabe si toca un martillo o un destornillador</a:t>
+            </a:r>
+          </a:p>
+        </p:txBody>
+      </p:sp>
+      <p:sp>
+        <p:nvSpPr>
+          <p:cNvPr id="71" name="Rectangle 70"/>
+          <p:cNvSpPr/>
+          <p:nvPr/>
+        </p:nvSpPr>
+        <p:spPr>
+          <a:xfrm>
+            <a:off x="8171688" y="3017520"/>
+            <a:ext cx="3230880" cy="2395728"/>
+          </a:xfrm>
+          <a:prstGeom prst="rect">
+            <a:avLst/>
+          </a:prstGeom>
+          <a:noFill/>
+          <a:ln w="9525">
+            <a:solidFill>
+              <a:srgbClr val="C6BFAE"/>
+            </a:solidFill>
+          </a:ln>
+          <a:effectLst/>
+        </p:spPr>
+        <p:style>
+          <a:lnRef idx="1">
+            <a:schemeClr val="accent1"/>
+          </a:lnRef>
+          <a:fillRef idx="3">
+            <a:schemeClr val="accent1"/>
+          </a:fillRef>
+          <a:effectRef idx="2">
+            <a:schemeClr val="accent1"/>
+          </a:effectRef>
+          <a:fontRef idx="minor">
+            <a:schemeClr val="lt1"/>
+          </a:fontRef>
+        </p:style>
+        <p:txBody>
+          <a:bodyPr rtlCol="0" anchor="ctr"/>
+          <a:lstStyle/>
+          <a:p>
+            <a:pPr algn="ctr"/>
+            <a:endParaRPr/>
+          </a:p>
+        </p:txBody>
+      </p:sp>
+      <p:sp>
+        <p:nvSpPr>
+          <p:cNvPr id="72" name="TextBox 71"/>
+          <p:cNvSpPr txBox="1"/>
+          <p:nvPr/>
+        </p:nvSpPr>
+        <p:spPr>
+          <a:xfrm>
+            <a:off x="8317992" y="3108960"/>
+            <a:ext cx="365760" cy="457200"/>
+          </a:xfrm>
+          <a:prstGeom prst="rect">
+            <a:avLst/>
+          </a:prstGeom>
+          <a:noFill/>
+        </p:spPr>
+        <p:txBody>
+          <a:bodyPr wrap="square" lIns="0" tIns="0" rIns="0" bIns="0" anchor="t">
+            <a:spAutoFit/>
+          </a:bodyPr>
+          <a:lstStyle/>
+          <a:p>
+            <a:pPr algn="l"/>
+            <a:r>
+              <a:rPr sz="2200" b="1" i="0">
+                <a:solidFill>
+                  <a:srgbClr val="984514"/>
+                </a:solidFill>
+                <a:latin typeface="Georgia"/>
+              </a:rPr>
+              <a:t>3</a:t>
+            </a:r>
+          </a:p>
+        </p:txBody>
+      </p:sp>
+      <p:sp>
+        <p:nvSpPr>
+          <p:cNvPr id="73" name="TextBox 72"/>
+          <p:cNvSpPr txBox="1"/>
+          <p:nvPr/>
+        </p:nvSpPr>
+        <p:spPr>
+          <a:xfrm>
+            <a:off x="8702040" y="3145536"/>
+            <a:ext cx="2590799" cy="457200"/>
+          </a:xfrm>
+          <a:prstGeom prst="rect">
+            <a:avLst/>
+          </a:prstGeom>
+          <a:noFill/>
+        </p:spPr>
+        <p:txBody>
+          <a:bodyPr wrap="square" lIns="0" tIns="0" rIns="0" bIns="0" anchor="t">
+            <a:spAutoFit/>
+          </a:bodyPr>
+          <a:lstStyle/>
+          <a:p>
+            <a:pPr algn="l">
+              <a:lnSpc>
+                <a:spcPct val="100000"/>
+              </a:lnSpc>
+            </a:pPr>
+            <a:r>
+              <a:rPr sz="1250" b="1" i="0">
+                <a:solidFill>
+                  <a:srgbClr val="16181D"/>
+                </a:solidFill>
+                <a:latin typeface="Arial"/>
+              </a:rPr>
+              <a:t>Es autónomo</a:t>
+            </a:r>
+          </a:p>
+          <a:p>
+            <a:pPr algn="l">
+              <a:lnSpc>
+                <a:spcPct val="100000"/>
+              </a:lnSpc>
+            </a:pPr>
+            <a:r>
+              <a:rPr sz="850" b="0" i="1">
+                <a:solidFill>
+                  <a:srgbClr val="0033A0"/>
+                </a:solidFill>
+                <a:latin typeface="Arial"/>
+              </a:rPr>
+              <a:t>decide qué hacer y cuándo</a:t>
+            </a:r>
+          </a:p>
+        </p:txBody>
+      </p:sp>
+      <p:sp>
+        <p:nvSpPr>
+          <p:cNvPr id="74" name="TextBox 73"/>
+          <p:cNvSpPr txBox="1"/>
+          <p:nvPr/>
+        </p:nvSpPr>
+        <p:spPr>
+          <a:xfrm>
+            <a:off x="8317992" y="3621024"/>
+            <a:ext cx="2938272" cy="411480"/>
+          </a:xfrm>
+          <a:prstGeom prst="rect">
+            <a:avLst/>
+          </a:prstGeom>
+          <a:noFill/>
+        </p:spPr>
+        <p:txBody>
+          <a:bodyPr wrap="square" lIns="0" tIns="0" rIns="0" bIns="0" anchor="t">
+            <a:spAutoFit/>
+          </a:bodyPr>
+          <a:lstStyle/>
+          <a:p>
+            <a:pPr algn="l"/>
+            <a:r>
+              <a:rPr sz="880" b="0" i="0">
+                <a:solidFill>
+                  <a:srgbClr val="585E6F"/>
+                </a:solidFill>
+                <a:latin typeface="Arial"/>
+              </a:rPr>
+              <a:t>Encadena pasos por su cuenta hasta terminar, a menos que explícitamente se le supervise.</a:t>
+            </a:r>
+          </a:p>
+        </p:txBody>
+      </p:sp>
+      <p:sp>
+        <p:nvSpPr>
+          <p:cNvPr id="75" name="Rectangle 74"/>
+          <p:cNvSpPr/>
+          <p:nvPr/>
+        </p:nvSpPr>
+        <p:spPr>
+          <a:xfrm>
+            <a:off x="8336280" y="4142231"/>
+            <a:ext cx="749808" cy="292608"/>
+          </a:xfrm>
+          <a:prstGeom prst="rect">
+            <a:avLst/>
+          </a:prstGeom>
+          <a:solidFill>
+            <a:srgbClr val="E3DCCB"/>
+          </a:solidFill>
+          <a:ln w="10160">
+            <a:solidFill>
+              <a:srgbClr val="585E6F"/>
+            </a:solidFill>
+          </a:ln>
+          <a:effectLst/>
+        </p:spPr>
+        <p:style>
+          <a:lnRef idx="1">
+            <a:schemeClr val="accent1"/>
+          </a:lnRef>
+          <a:fillRef idx="3">
+            <a:schemeClr val="accent1"/>
+          </a:fillRef>
+          <a:effectRef idx="2">
+            <a:schemeClr val="accent1"/>
+          </a:effectRef>
+          <a:fontRef idx="minor">
+            <a:schemeClr val="lt1"/>
+          </a:fontRef>
+        </p:style>
+        <p:txBody>
+          <a:bodyPr rtlCol="0" anchor="ctr"/>
+          <a:lstStyle/>
+          <a:p>
+            <a:pPr algn="ctr"/>
+            <a:endParaRPr/>
+          </a:p>
+        </p:txBody>
+      </p:sp>
+      <p:sp>
+        <p:nvSpPr>
+          <p:cNvPr id="76" name="TextBox 75"/>
+          <p:cNvSpPr txBox="1"/>
+          <p:nvPr/>
+        </p:nvSpPr>
+        <p:spPr>
+          <a:xfrm>
+            <a:off x="8336280" y="4142231"/>
+            <a:ext cx="749808" cy="292608"/>
+          </a:xfrm>
+          <a:prstGeom prst="rect">
+            <a:avLst/>
+          </a:prstGeom>
+          <a:noFill/>
+        </p:spPr>
+        <p:txBody>
+          <a:bodyPr wrap="square" lIns="0" tIns="0" rIns="0" bIns="0" anchor="ctr">
+            <a:spAutoFit/>
+          </a:bodyPr>
+          <a:lstStyle/>
+          <a:p>
+            <a:pPr algn="ctr"/>
+            <a:r>
+              <a:rPr sz="800" b="1" i="0">
+                <a:solidFill>
+                  <a:srgbClr val="16181D"/>
+                </a:solidFill>
+                <a:latin typeface="Arial"/>
+              </a:rPr>
+              <a:t>piensa</a:t>
+            </a:r>
+          </a:p>
+        </p:txBody>
+      </p:sp>
+      <p:cxnSp>
+        <p:nvCxnSpPr>
+          <p:cNvPr id="77" name="Connector 76"/>
+          <p:cNvCxnSpPr/>
+          <p:nvPr/>
+        </p:nvCxnSpPr>
+        <p:spPr>
+          <a:xfrm>
+            <a:off x="9086088" y="4288536"/>
+            <a:ext cx="274320" cy="0"/>
+          </a:xfrm>
+          <a:prstGeom prst="line">
+            <a:avLst/>
+          </a:prstGeom>
+          <a:ln w="12700">
+            <a:solidFill>
+              <a:srgbClr val="585E6F"/>
+            </a:solidFill>
+            <a:tailEnd type="triangle" w="sm" len="sm"/>
+          </a:ln>
+        </p:spPr>
+        <p:style>
+          <a:lnRef idx="2">
+            <a:schemeClr val="accent1"/>
+          </a:lnRef>
+          <a:fillRef idx="0">
+            <a:schemeClr val="accent1"/>
+          </a:fillRef>
+          <a:effectRef idx="1">
+            <a:schemeClr val="accent1"/>
+          </a:effectRef>
+          <a:fontRef idx="minor">
+            <a:schemeClr val="tx1"/>
+          </a:fontRef>
+        </p:style>
+      </p:cxnSp>
+      <p:sp>
+        <p:nvSpPr>
+          <p:cNvPr id="78" name="Rectangle 77"/>
+          <p:cNvSpPr/>
+          <p:nvPr/>
+        </p:nvSpPr>
+        <p:spPr>
+          <a:xfrm>
+            <a:off x="9360408" y="4142231"/>
+            <a:ext cx="749808" cy="292608"/>
+          </a:xfrm>
+          <a:prstGeom prst="rect">
+            <a:avLst/>
+          </a:prstGeom>
+          <a:solidFill>
+            <a:srgbClr val="E3DCCB"/>
+          </a:solidFill>
+          <a:ln w="10160">
+            <a:solidFill>
+              <a:srgbClr val="585E6F"/>
+            </a:solidFill>
+          </a:ln>
+          <a:effectLst/>
+        </p:spPr>
+        <p:style>
+          <a:lnRef idx="1">
+            <a:schemeClr val="accent1"/>
+          </a:lnRef>
+          <a:fillRef idx="3">
+            <a:schemeClr val="accent1"/>
+          </a:fillRef>
+          <a:effectRef idx="2">
+            <a:schemeClr val="accent1"/>
+          </a:effectRef>
+          <a:fontRef idx="minor">
+            <a:schemeClr val="lt1"/>
+          </a:fontRef>
+        </p:style>
+        <p:txBody>
+          <a:bodyPr rtlCol="0" anchor="ctr"/>
+          <a:lstStyle/>
+          <a:p>
+            <a:pPr algn="ctr"/>
+            <a:endParaRPr/>
+          </a:p>
+        </p:txBody>
+      </p:sp>
+      <p:sp>
+        <p:nvSpPr>
+          <p:cNvPr id="79" name="TextBox 78"/>
+          <p:cNvSpPr txBox="1"/>
+          <p:nvPr/>
+        </p:nvSpPr>
+        <p:spPr>
+          <a:xfrm>
+            <a:off x="9360408" y="4142231"/>
+            <a:ext cx="749808" cy="292608"/>
+          </a:xfrm>
+          <a:prstGeom prst="rect">
+            <a:avLst/>
+          </a:prstGeom>
+          <a:noFill/>
+        </p:spPr>
+        <p:txBody>
+          <a:bodyPr wrap="square" lIns="0" tIns="0" rIns="0" bIns="0" anchor="ctr">
+            <a:spAutoFit/>
+          </a:bodyPr>
+          <a:lstStyle/>
+          <a:p>
+            <a:pPr algn="ctr"/>
+            <a:r>
+              <a:rPr sz="800" b="1" i="0">
+                <a:solidFill>
+                  <a:srgbClr val="16181D"/>
+                </a:solidFill>
+                <a:latin typeface="Arial"/>
+              </a:rPr>
+              <a:t>actúa</a:t>
+            </a:r>
+          </a:p>
+        </p:txBody>
+      </p:sp>
+      <p:cxnSp>
+        <p:nvCxnSpPr>
+          <p:cNvPr id="80" name="Connector 79"/>
+          <p:cNvCxnSpPr/>
+          <p:nvPr/>
+        </p:nvCxnSpPr>
+        <p:spPr>
+          <a:xfrm>
+            <a:off x="10110216" y="4288536"/>
+            <a:ext cx="274320" cy="0"/>
+          </a:xfrm>
+          <a:prstGeom prst="line">
+            <a:avLst/>
+          </a:prstGeom>
+          <a:ln w="12700">
+            <a:solidFill>
+              <a:srgbClr val="585E6F"/>
+            </a:solidFill>
+            <a:tailEnd type="triangle" w="sm" len="sm"/>
+          </a:ln>
+        </p:spPr>
+        <p:style>
+          <a:lnRef idx="2">
+            <a:schemeClr val="accent1"/>
+          </a:lnRef>
+          <a:fillRef idx="0">
+            <a:schemeClr val="accent1"/>
+          </a:fillRef>
+          <a:effectRef idx="1">
+            <a:schemeClr val="accent1"/>
+          </a:effectRef>
+          <a:fontRef idx="minor">
+            <a:schemeClr val="tx1"/>
+          </a:fontRef>
+        </p:style>
+      </p:cxnSp>
+      <p:sp>
+        <p:nvSpPr>
+          <p:cNvPr id="81" name="Rectangle 80"/>
+          <p:cNvSpPr/>
+          <p:nvPr/>
+        </p:nvSpPr>
+        <p:spPr>
+          <a:xfrm>
+            <a:off x="10384536" y="4142231"/>
+            <a:ext cx="749808" cy="292608"/>
+          </a:xfrm>
+          <a:prstGeom prst="rect">
+            <a:avLst/>
+          </a:prstGeom>
+          <a:solidFill>
+            <a:srgbClr val="E3DCCB"/>
+          </a:solidFill>
+          <a:ln w="10160">
+            <a:solidFill>
+              <a:srgbClr val="585E6F"/>
+            </a:solidFill>
+          </a:ln>
+          <a:effectLst/>
+        </p:spPr>
+        <p:style>
+          <a:lnRef idx="1">
+            <a:schemeClr val="accent1"/>
+          </a:lnRef>
+          <a:fillRef idx="3">
+            <a:schemeClr val="accent1"/>
+          </a:fillRef>
+          <a:effectRef idx="2">
+            <a:schemeClr val="accent1"/>
+          </a:effectRef>
+          <a:fontRef idx="minor">
+            <a:schemeClr val="lt1"/>
+          </a:fontRef>
+        </p:style>
+        <p:txBody>
+          <a:bodyPr rtlCol="0" anchor="ctr"/>
+          <a:lstStyle/>
+          <a:p>
+            <a:pPr algn="ctr"/>
+            <a:endParaRPr/>
+          </a:p>
+        </p:txBody>
+      </p:sp>
+      <p:sp>
+        <p:nvSpPr>
+          <p:cNvPr id="82" name="TextBox 81"/>
+          <p:cNvSpPr txBox="1"/>
+          <p:nvPr/>
+        </p:nvSpPr>
+        <p:spPr>
+          <a:xfrm>
+            <a:off x="10384536" y="4142231"/>
+            <a:ext cx="749808" cy="292608"/>
+          </a:xfrm>
+          <a:prstGeom prst="rect">
+            <a:avLst/>
+          </a:prstGeom>
+          <a:noFill/>
+        </p:spPr>
+        <p:txBody>
+          <a:bodyPr wrap="square" lIns="0" tIns="0" rIns="0" bIns="0" anchor="ctr">
+            <a:spAutoFit/>
+          </a:bodyPr>
+          <a:lstStyle/>
+          <a:p>
+            <a:pPr algn="ctr"/>
+            <a:r>
+              <a:rPr sz="800" b="1" i="0">
+                <a:solidFill>
+                  <a:srgbClr val="16181D"/>
+                </a:solidFill>
+                <a:latin typeface="Arial"/>
+              </a:rPr>
+              <a:t>observa</a:t>
+            </a:r>
+          </a:p>
+        </p:txBody>
+      </p:sp>
+      <p:cxnSp>
+        <p:nvCxnSpPr>
+          <p:cNvPr id="83" name="Connector 82"/>
+          <p:cNvCxnSpPr/>
+          <p:nvPr/>
+        </p:nvCxnSpPr>
+        <p:spPr>
+          <a:xfrm>
+            <a:off x="10759440" y="4434840"/>
+            <a:ext cx="0" cy="118872"/>
+          </a:xfrm>
+          <a:prstGeom prst="line">
+            <a:avLst/>
+          </a:prstGeom>
+          <a:ln w="12700">
+            <a:solidFill>
+              <a:srgbClr val="585E6F"/>
+            </a:solidFill>
+          </a:ln>
+        </p:spPr>
+        <p:style>
+          <a:lnRef idx="2">
+            <a:schemeClr val="accent1"/>
+          </a:lnRef>
+          <a:fillRef idx="0">
+            <a:schemeClr val="accent1"/>
+          </a:fillRef>
+          <a:effectRef idx="1">
+            <a:schemeClr val="accent1"/>
+          </a:effectRef>
+          <a:fontRef idx="minor">
+            <a:schemeClr val="tx1"/>
+          </a:fontRef>
+        </p:style>
+      </p:cxnSp>
+      <p:cxnSp>
+        <p:nvCxnSpPr>
+          <p:cNvPr id="84" name="Connector 83"/>
+          <p:cNvCxnSpPr/>
+          <p:nvPr/>
+        </p:nvCxnSpPr>
+        <p:spPr>
+          <a:xfrm flipH="1">
+            <a:off x="8711184" y="4553712"/>
+            <a:ext cx="2048256" cy="0"/>
+          </a:xfrm>
+          <a:prstGeom prst="line">
+            <a:avLst/>
+          </a:prstGeom>
+          <a:ln w="12700">
+            <a:solidFill>
+              <a:srgbClr val="585E6F"/>
+            </a:solidFill>
+          </a:ln>
+        </p:spPr>
+        <p:style>
+          <a:lnRef idx="2">
+            <a:schemeClr val="accent1"/>
+          </a:lnRef>
+          <a:fillRef idx="0">
+            <a:schemeClr val="accent1"/>
+          </a:fillRef>
+          <a:effectRef idx="1">
+            <a:schemeClr val="accent1"/>
+          </a:effectRef>
+          <a:fontRef idx="minor">
+            <a:schemeClr val="tx1"/>
+          </a:fontRef>
+        </p:style>
+      </p:cxnSp>
+      <p:cxnSp>
+        <p:nvCxnSpPr>
+          <p:cNvPr id="85" name="Connector 84"/>
+          <p:cNvCxnSpPr/>
+          <p:nvPr/>
+        </p:nvCxnSpPr>
+        <p:spPr>
+          <a:xfrm flipV="1">
+            <a:off x="8711184" y="4434840"/>
+            <a:ext cx="0" cy="118872"/>
+          </a:xfrm>
+          <a:prstGeom prst="line">
+            <a:avLst/>
+          </a:prstGeom>
+          <a:ln w="12700">
+            <a:solidFill>
+              <a:srgbClr val="585E6F"/>
+            </a:solidFill>
+            <a:tailEnd type="triangle" w="sm" len="sm"/>
+          </a:ln>
+        </p:spPr>
+        <p:style>
+          <a:lnRef idx="2">
+            <a:schemeClr val="accent1"/>
+          </a:lnRef>
+          <a:fillRef idx="0">
+            <a:schemeClr val="accent1"/>
+          </a:fillRef>
+          <a:effectRef idx="1">
+            <a:schemeClr val="accent1"/>
+          </a:effectRef>
+          <a:fontRef idx="minor">
+            <a:schemeClr val="tx1"/>
+          </a:fontRef>
+        </p:style>
+      </p:cxnSp>
+      <p:sp>
+        <p:nvSpPr>
+          <p:cNvPr id="86" name="Rectangle 85"/>
+          <p:cNvSpPr/>
+          <p:nvPr/>
+        </p:nvSpPr>
+        <p:spPr>
+          <a:xfrm>
+            <a:off x="8336280" y="4645151"/>
+            <a:ext cx="2901696" cy="256032"/>
+          </a:xfrm>
+          <a:prstGeom prst="rect">
+            <a:avLst/>
+          </a:prstGeom>
+          <a:noFill/>
+          <a:ln w="12700">
+            <a:solidFill>
+              <a:srgbClr val="984514"/>
+            </a:solidFill>
+            <a:prstDash val="dash"/>
+          </a:ln>
+          <a:effectLst/>
+        </p:spPr>
+        <p:style>
+          <a:lnRef idx="1">
+            <a:schemeClr val="accent1"/>
+          </a:lnRef>
+          <a:fillRef idx="3">
+            <a:schemeClr val="accent1"/>
+          </a:fillRef>
+          <a:effectRef idx="2">
+            <a:schemeClr val="accent1"/>
+          </a:effectRef>
+          <a:fontRef idx="minor">
+            <a:schemeClr val="lt1"/>
+          </a:fontRef>
+        </p:style>
+        <p:txBody>
+          <a:bodyPr rtlCol="0" anchor="ctr"/>
+          <a:lstStyle/>
+          <a:p>
+            <a:pPr algn="ctr"/>
+            <a:endParaRPr/>
+          </a:p>
+        </p:txBody>
+      </p:sp>
+      <p:sp>
+        <p:nvSpPr>
+          <p:cNvPr id="87" name="TextBox 86"/>
+          <p:cNvSpPr txBox="1"/>
+          <p:nvPr/>
+        </p:nvSpPr>
+        <p:spPr>
+          <a:xfrm>
+            <a:off x="8336280" y="4645151"/>
+            <a:ext cx="2901696" cy="256032"/>
+          </a:xfrm>
+          <a:prstGeom prst="rect">
+            <a:avLst/>
+          </a:prstGeom>
+          <a:noFill/>
+        </p:spPr>
+        <p:txBody>
+          <a:bodyPr wrap="square" lIns="0" tIns="0" rIns="0" bIns="0" anchor="ctr">
+            <a:spAutoFit/>
+          </a:bodyPr>
+          <a:lstStyle/>
+          <a:p>
+            <a:pPr algn="ctr"/>
+            <a:r>
+              <a:rPr sz="750" b="1" i="0">
+                <a:solidFill>
+                  <a:srgbClr val="984514"/>
+                </a:solidFill>
+                <a:latin typeface="Arial"/>
+              </a:rPr>
+              <a:t>salvo supervisión: una persona aprueba lo irreversible</a:t>
+            </a:r>
+          </a:p>
+        </p:txBody>
+      </p:sp>
+      <p:sp>
+        <p:nvSpPr>
+          <p:cNvPr id="88" name="Rectangle 87"/>
+          <p:cNvSpPr/>
+          <p:nvPr/>
+        </p:nvSpPr>
+        <p:spPr>
+          <a:xfrm>
+            <a:off x="8317992" y="5001768"/>
+            <a:ext cx="2938272" cy="301752"/>
+          </a:xfrm>
+          <a:prstGeom prst="rect">
+            <a:avLst/>
+          </a:prstGeom>
+          <a:solidFill>
+            <a:srgbClr val="E6DFCF"/>
+          </a:solidFill>
+          <a:ln>
+            <a:noFill/>
+          </a:ln>
+          <a:effectLst/>
+        </p:spPr>
+        <p:style>
+          <a:lnRef idx="1">
+            <a:schemeClr val="accent1"/>
+          </a:lnRef>
+          <a:fillRef idx="3">
+            <a:schemeClr val="accent1"/>
+          </a:fillRef>
+          <a:effectRef idx="2">
+            <a:schemeClr val="accent1"/>
+          </a:effectRef>
+          <a:fontRef idx="minor">
+            <a:schemeClr val="lt1"/>
+          </a:fontRef>
+        </p:style>
+        <p:txBody>
+          <a:bodyPr rtlCol="0" anchor="ctr"/>
+          <a:lstStyle/>
+          <a:p>
+            <a:pPr algn="ctr"/>
+            <a:endParaRPr/>
+          </a:p>
+        </p:txBody>
+      </p:sp>
+      <p:sp>
+        <p:nvSpPr>
+          <p:cNvPr id="89" name="TextBox 88"/>
+          <p:cNvSpPr txBox="1"/>
+          <p:nvPr/>
+        </p:nvSpPr>
+        <p:spPr>
+          <a:xfrm>
+            <a:off x="8391144" y="5001768"/>
+            <a:ext cx="2865120" cy="301752"/>
+          </a:xfrm>
+          <a:prstGeom prst="rect">
+            <a:avLst/>
+          </a:prstGeom>
+          <a:noFill/>
+        </p:spPr>
+        <p:txBody>
+          <a:bodyPr wrap="square" lIns="0" tIns="0" rIns="0" bIns="0" anchor="ctr">
+            <a:spAutoFit/>
+          </a:bodyPr>
+          <a:lstStyle/>
+          <a:p>
+            <a:pPr algn="l"/>
+            <a:r>
+              <a:rPr sz="830" b="1" i="0">
+                <a:solidFill>
+                  <a:srgbClr val="16181D"/>
+                </a:solidFill>
+                <a:latin typeface="Arial"/>
+              </a:rPr>
+              <a:t>Como un humano: </a:t>
+            </a:r>
+            <a:r>
+              <a:rPr sz="830" b="0" i="0">
+                <a:solidFill>
+                  <a:srgbClr val="585E6F"/>
+                </a:solidFill>
+                <a:latin typeface="Arial"/>
+              </a:rPr>
+              <a:t>como un empleado de confianza que pide firma en lo delicado</a:t>
+            </a:r>
+          </a:p>
+        </p:txBody>
+      </p:sp>
+      <p:sp>
+        <p:nvSpPr>
+          <p:cNvPr id="90" name="Rectangle 89"/>
+          <p:cNvSpPr/>
+          <p:nvPr/>
+        </p:nvSpPr>
+        <p:spPr>
+          <a:xfrm>
+            <a:off x="1344168" y="5541264"/>
+            <a:ext cx="10058400" cy="457200"/>
+          </a:xfrm>
+          <a:prstGeom prst="rect">
+            <a:avLst/>
+          </a:prstGeom>
+          <a:solidFill>
+            <a:srgbClr val="E3DCCB"/>
+          </a:solidFill>
+          <a:ln>
+            <a:noFill/>
+          </a:ln>
+          <a:effectLst/>
+        </p:spPr>
+        <p:style>
+          <a:lnRef idx="1">
+            <a:schemeClr val="accent1"/>
+          </a:lnRef>
+          <a:fillRef idx="3">
+            <a:schemeClr val="accent1"/>
+          </a:fillRef>
+          <a:effectRef idx="2">
+            <a:schemeClr val="accent1"/>
+          </a:effectRef>
+          <a:fontRef idx="minor">
+            <a:schemeClr val="lt1"/>
+          </a:fontRef>
+        </p:style>
+        <p:txBody>
+          <a:bodyPr rtlCol="0" anchor="ctr"/>
+          <a:lstStyle/>
+          <a:p>
+            <a:pPr algn="ctr"/>
+            <a:endParaRPr/>
+          </a:p>
+        </p:txBody>
+      </p:sp>
+      <p:sp>
+        <p:nvSpPr>
+          <p:cNvPr id="91" name="Rectangle 90"/>
+          <p:cNvSpPr/>
+          <p:nvPr/>
+        </p:nvSpPr>
+        <p:spPr>
+          <a:xfrm>
+            <a:off x="1344168" y="5541264"/>
+            <a:ext cx="45720" cy="457200"/>
+          </a:xfrm>
+          <a:prstGeom prst="rect">
+            <a:avLst/>
+          </a:prstGeom>
+          <a:solidFill>
+            <a:srgbClr val="984514"/>
+          </a:solidFill>
+          <a:ln>
+            <a:noFill/>
+          </a:ln>
+          <a:effectLst/>
+        </p:spPr>
+        <p:style>
+          <a:lnRef idx="1">
+            <a:schemeClr val="accent1"/>
+          </a:lnRef>
+          <a:fillRef idx="3">
+            <a:schemeClr val="accent1"/>
+          </a:fillRef>
+          <a:effectRef idx="2">
+            <a:schemeClr val="accent1"/>
+          </a:effectRef>
+          <a:fontRef idx="minor">
+            <a:schemeClr val="lt1"/>
+          </a:fontRef>
+        </p:style>
+        <p:txBody>
+          <a:bodyPr rtlCol="0" anchor="ctr"/>
+          <a:lstStyle/>
+          <a:p>
+            <a:pPr algn="ctr"/>
+            <a:endParaRPr/>
+          </a:p>
+        </p:txBody>
+      </p:sp>
+      <p:sp>
+        <p:nvSpPr>
+          <p:cNvPr id="92" name="TextBox 91"/>
+          <p:cNvSpPr txBox="1"/>
+          <p:nvPr/>
+        </p:nvSpPr>
+        <p:spPr>
+          <a:xfrm>
+            <a:off x="1527048" y="5541264"/>
+            <a:ext cx="9784080" cy="457200"/>
+          </a:xfrm>
+          <a:prstGeom prst="rect">
+            <a:avLst/>
+          </a:prstGeom>
+          <a:noFill/>
+        </p:spPr>
+        <p:txBody>
+          <a:bodyPr wrap="square" lIns="0" tIns="0" rIns="0" bIns="0" anchor="ctr">
+            <a:spAutoFit/>
+          </a:bodyPr>
+          <a:lstStyle/>
+          <a:p>
+            <a:pPr algn="l"/>
+            <a:r>
+              <a:rPr sz="1100" b="1" i="0">
+                <a:solidFill>
+                  <a:srgbClr val="0033A0"/>
+                </a:solidFill>
+                <a:latin typeface="Arial"/>
+              </a:rPr>
+              <a:t>Lenguaje + herramientas + autonomía = agente. </a:t>
+            </a:r>
+            <a:r>
+              <a:rPr sz="1100" b="0" i="0">
+                <a:solidFill>
+                  <a:srgbClr val="16181D"/>
+                </a:solidFill>
+                <a:latin typeface="Arial"/>
+              </a:rPr>
+              <a:t>Un chatbot conversa; un agente actúa.</a:t>
+            </a:r>
           </a:p>
         </p:txBody>
       </p:sp>

</xml_diff>